<commit_message>
Lead facilitator sees cohort and all modules
</commit_message>
<xml_diff>
--- a/Claude outputs/Deck upload/Module-3/unit-05.pptx
+++ b/Claude outputs/Deck upload/Module-3/unit-05.pptx
@@ -316,7 +316,7 @@
           <a:lstStyle/>
           <a:p>
             <a:r>
-              <a:rPr lang="en-GB" b="1" dirty="0"/>
+              <a:rPr lang="en-GB" dirty="0" b="1"/>
               <a:t>UNIT 5 · ALIGNING HEART &amp; MIND</a:t>
             </a:r>
           </a:p>
@@ -326,12 +326,10 @@
               <a:t>Module 3 · Influence · Unit 5</a:t>
             </a:r>
           </a:p>
-          <a:p>
-            <a:endParaRPr lang="en-GB" dirty="0"/>
-          </a:p>
-          <a:p>
-            <a:r>
-              <a:rPr lang="en-GB" b="1" dirty="0"/>
+          <a:p/>
+          <a:p>
+            <a:r>
+              <a:rPr lang="en-GB" dirty="0" b="1"/>
               <a:t>UNIT INTENT</a:t>
             </a:r>
           </a:p>
@@ -347,30 +345,37 @@
               <a:t>The unit builds a shared enterprise interpretation and the behaviours that sustain commitment.</a:t>
             </a:r>
           </a:p>
-          <a:p>
-            <a:endParaRPr lang="en-GB" dirty="0"/>
-          </a:p>
+          <a:p/>
           <a:p>
             <a:r>
               <a:rPr lang="en-GB" dirty="0"/>
               <a:t>SCARF explains resistance, ACE-IT sets the behaviour standard and the OCEAVL Assessment shows the behavioural profile the leadership team brings to the strategy.</a:t>
             </a:r>
           </a:p>
-          <a:p>
-            <a:endParaRPr lang="en-GB" dirty="0"/>
-          </a:p>
+          <a:p/>
           <a:p>
             <a:r>
               <a:rPr lang="en-GB" dirty="0"/>
               <a:t>The 4 Checks of Mind, Heart, Hands and Habit give leaders one discipline for leading people through the changes the strategy requires: 3S tests Mind, SCARF reads Heart, STAT tests Hands and ACE-IT holds Habit.</a:t>
             </a:r>
           </a:p>
-          <a:p>
-            <a:endParaRPr lang="en-GB" dirty="0"/>
-          </a:p>
-          <a:p>
-            <a:r>
-              <a:rPr lang="en-GB" b="1" dirty="0"/>
+          <a:p/>
+          <a:p>
+            <a:r>
+              <a:rPr lang="en-GB" dirty="0" b="1"/>
+              <a:t>WHERE THE UNIT SITS:</a:t>
+            </a:r>
+          </a:p>
+          <a:p>
+            <a:r>
+              <a:rPr lang="en-GB" dirty="0"/>
+              <a:t>Unit 5 opens Module 3, Influence. Influence mobilises the people and performance systems through which strategy is carried into execution. The module moves from Unit 5, Aligning Heart &amp; Mind (people alignment), to Unit 6, Performance Management Setup (performance architecture), Unit 7, Establishing Performance Expectations (owned commitments), Unit 8, Performance Measurement (review discipline), and Unit 9, Strategic Unclogging (flow of execution).</a:t>
+            </a:r>
+          </a:p>
+          <a:p/>
+          <a:p>
+            <a:r>
+              <a:rPr lang="en-GB" dirty="0" b="1"/>
               <a:t>WHAT THE UNIT PRODUCES:</a:t>
             </a:r>
           </a:p>
@@ -392,12 +397,10 @@
               <a:t>3. Each participant writes thirteen reflections.</a:t>
             </a:r>
           </a:p>
-          <a:p>
-            <a:endParaRPr lang="en-GB" dirty="0"/>
-          </a:p>
-          <a:p>
-            <a:r>
-              <a:rPr lang="en-GB" b="1" dirty="0"/>
+          <a:p/>
+          <a:p>
+            <a:r>
+              <a:rPr lang="en-GB" dirty="0" b="1"/>
               <a:t>HOW THE UNIT RUNS:</a:t>
             </a:r>
           </a:p>
@@ -425,18 +428,14 @@
               <a:t>The scribe types what the group agrees, the entries appear on every member’s page, and each member then selects Agree.</a:t>
             </a:r>
           </a:p>
-          <a:p>
-            <a:endParaRPr lang="en-GB" dirty="0"/>
-          </a:p>
+          <a:p/>
           <a:p>
             <a:r>
               <a:rPr lang="en-GB" dirty="0"/>
               <a:t>Each slide’s notes end with a block headed "On the portal, after the teaching" wherever participants have something to complete for that part.</a:t>
             </a:r>
           </a:p>
-          <a:p>
-            <a:endParaRPr lang="en-GB" dirty="0"/>
-          </a:p>
+          <a:p/>
           <a:p>
             <a:r>
               <a:rPr lang="en-GB" dirty="0"/>
@@ -473,9 +472,7 @@
               <a:t>- Step 2 of Section 5 shows the team’s OCEAVL profile. Every member of a team completes and submits the assessment in 3.1 first.</a:t>
             </a:r>
           </a:p>
-          <a:p>
-            <a:endParaRPr lang="en-GB" dirty="0"/>
-          </a:p>
+          <a:p/>
           <a:p>
             <a:r>
               <a:rPr lang="en-GB" dirty="0"/>
@@ -485,13 +482,13 @@
           <a:p>
             <a:r>
               <a:rPr lang="en-GB" dirty="0"/>
-              <a:t>- Each member’s submitted OCEAVL scores feed the team’s profile in the Capstone Blueprint once every member has submitted. The team sees levels and counts, with no names.</a:t>
-            </a:r>
-          </a:p>
-          <a:p>
-            <a:r>
-              <a:rPr lang="en-GB" dirty="0"/>
-              <a:t>- The group’s confirmed record from Section 5 feeds boxes 5B and 5C. The team writes box 5A under its team profile.</a:t>
+              <a:t>- Each member’s submitted OCEAVL scores feed the team’s profile in the Capstone S2R® Blueprint once every member has submitted. The team sees levels and counts, with no names.</a:t>
+            </a:r>
+          </a:p>
+          <a:p>
+            <a:r>
+              <a:rPr lang="en-GB" dirty="0"/>
+              <a:t>- The group’s agreed record from Section 5 feeds boxes 5A to 5C of the Capstone S2R® Blueprint: the two highest-risk dimensions in 5A, the Shift, Stake and Step in 5B and the expected leadership behaviours in 5C.</a:t>
             </a:r>
           </a:p>
         </p:txBody>
@@ -3603,25 +3600,21 @@
           <a:lstStyle/>
           <a:p>
             <a:r>
-              <a:rPr lang="en-GB" b="1" dirty="0"/>
+              <a:rPr lang="en-GB" dirty="0" b="1"/>
               <a:t>SECTION 1 REFLECTIONS · 1.3.1 TO 1.3.4</a:t>
             </a:r>
           </a:p>
-          <a:p>
-            <a:endParaRPr lang="en-GB" dirty="0"/>
-          </a:p>
-          <a:p>
-            <a:r>
-              <a:rPr lang="en-GB" b="1" dirty="0"/>
+          <a:p/>
+          <a:p>
+            <a:r>
+              <a:rPr lang="en-GB" dirty="0" b="1"/>
               <a:t>HOW TO USE THIS SLIDE:</a:t>
             </a:r>
           </a:p>
-          <a:p>
-            <a:endParaRPr lang="en-GB" dirty="0"/>
-          </a:p>
-          <a:p>
-            <a:r>
-              <a:rPr lang="en-GB" b="1" dirty="0"/>
+          <a:p/>
+          <a:p>
+            <a:r>
+              <a:rPr lang="en-GB" dirty="0" b="1"/>
               <a:t>1. Show the slide and read the prompts aloud.</a:t>
             </a:r>
           </a:p>
@@ -3631,39 +3624,31 @@
               <a:t>1.3.1 Reflection — The 3S Check: "Write the Shift, the Stake and the Step for the change you are carrying through this unit. Which of the three would your people find hardest to say back, and why?"</a:t>
             </a:r>
           </a:p>
-          <a:p>
-            <a:endParaRPr lang="en-GB" dirty="0"/>
-          </a:p>
+          <a:p/>
           <a:p>
             <a:r>
               <a:rPr lang="en-GB" dirty="0"/>
               <a:t>1.3.2 Reflection: "Which SCARF trigger is most frequently activated in your organisation during strategy implementation? What is the observable evidence? What counter-strategy would address the root cause?"</a:t>
             </a:r>
           </a:p>
-          <a:p>
-            <a:endParaRPr lang="en-GB" dirty="0"/>
-          </a:p>
+          <a:p/>
           <a:p>
             <a:r>
               <a:rPr lang="en-GB" dirty="0"/>
               <a:t>1.3.3 Reflection — The STAT Check: "Run STAT for the change you are carrying through this unit. Which element is missing for the people it affects most? What is your evidence, and what is yours to supply?"</a:t>
             </a:r>
           </a:p>
-          <a:p>
-            <a:endParaRPr lang="en-GB" dirty="0"/>
-          </a:p>
+          <a:p/>
           <a:p>
             <a:r>
               <a:rPr lang="en-GB" dirty="0"/>
               <a:t>1.3.4 Reflection: "If you audited your last leadership review against the ACE-IT behaviours — where would you find the biggest gap between the ideal and the observable? What one behavioural change would create the most impact?"</a:t>
             </a:r>
           </a:p>
-          <a:p>
-            <a:endParaRPr lang="en-GB" dirty="0"/>
-          </a:p>
-          <a:p>
-            <a:r>
-              <a:rPr lang="en-GB" b="1" dirty="0"/>
+          <a:p/>
+          <a:p>
+            <a:r>
+              <a:rPr lang="en-GB" dirty="0" b="1"/>
               <a:t>2. Say what the reflections are for.</a:t>
             </a:r>
           </a:p>
@@ -3679,21 +3664,17 @@
               <a:t>The reflections build the learning portfolio they receive at the end of the programme.</a:t>
             </a:r>
           </a:p>
-          <a:p>
-            <a:endParaRPr lang="en-GB" dirty="0"/>
-          </a:p>
+          <a:p/>
           <a:p>
             <a:r>
               <a:rPr lang="en-GB" dirty="0"/>
               <a:t>Say: "You write these reflections on the portal after the teaching, with as much depth as you can."</a:t>
             </a:r>
           </a:p>
-          <a:p>
-            <a:endParaRPr lang="en-GB" dirty="0"/>
-          </a:p>
-          <a:p>
-            <a:r>
-              <a:rPr lang="en-GB" b="1" dirty="0"/>
+          <a:p/>
+          <a:p>
+            <a:r>
+              <a:rPr lang="en-GB" dirty="0" b="1"/>
               <a:t>3. Set the standard.</a:t>
             </a:r>
           </a:p>
@@ -3721,27 +3702,23 @@
               <a:t>Watch for: resistance named with no trigger. Ask: "Which of the five triggers is live?"</a:t>
             </a:r>
           </a:p>
-          <a:p>
-            <a:endParaRPr lang="en-GB" dirty="0"/>
-          </a:p>
-          <a:p>
-            <a:r>
-              <a:rPr lang="en-GB" b="1" dirty="0"/>
-              <a:t>4. Bridge to Section 2.</a:t>
-            </a:r>
-          </a:p>
-          <a:p>
-            <a:r>
-              <a:rPr lang="en-GB" dirty="0"/>
-              <a:t>Say: "We know what alignment is and what a change must pass. Section 2 shows why this decides execution outcomes."</a:t>
-            </a:r>
-          </a:p>
-          <a:p>
-            <a:endParaRPr lang="en-GB" dirty="0"/>
-          </a:p>
-          <a:p>
-            <a:r>
-              <a:rPr lang="en-GB" b="1" dirty="0"/>
+          <a:p/>
+          <a:p>
+            <a:r>
+              <a:rPr lang="en-GB" dirty="0" b="1"/>
+              <a:t>4. Close Section 1 and bridge to Section 2.</a:t>
+            </a:r>
+          </a:p>
+          <a:p>
+            <a:r>
+              <a:rPr lang="en-GB" dirty="0"/>
+              <a:t>Say: "Leaders who address both the mind and the heart prepare people to understand, accept and act on the change a strategy requires. Section 2 examines why aligning heart and mind determines execution outcomes, and why change must be led to adoption."</a:t>
+            </a:r>
+          </a:p>
+          <a:p/>
+          <a:p>
+            <a:r>
+              <a:rPr lang="en-GB" dirty="0" b="1"/>
               <a:t>ON THE PORTAL, AFTER THE TEACHING:</a:t>
             </a:r>
           </a:p>
@@ -5180,25 +5157,21 @@
           <a:lstStyle/>
           <a:p>
             <a:r>
-              <a:rPr lang="en-GB" b="1" dirty="0"/>
+              <a:rPr lang="en-GB" dirty="0" b="1"/>
               <a:t>SECTION 2 REFLECTIONS</a:t>
             </a:r>
           </a:p>
-          <a:p>
-            <a:endParaRPr lang="en-GB" dirty="0"/>
-          </a:p>
-          <a:p>
-            <a:r>
-              <a:rPr lang="en-GB" b="1" dirty="0"/>
+          <a:p/>
+          <a:p>
+            <a:r>
+              <a:rPr lang="en-GB" dirty="0" b="1"/>
               <a:t>HOW TO USE THIS SLIDE:</a:t>
             </a:r>
           </a:p>
-          <a:p>
-            <a:endParaRPr lang="en-GB" dirty="0"/>
-          </a:p>
-          <a:p>
-            <a:r>
-              <a:rPr lang="en-GB" b="1" dirty="0"/>
+          <a:p/>
+          <a:p>
+            <a:r>
+              <a:rPr lang="en-GB" dirty="0" b="1"/>
               <a:t>1. Show the slide and read the prompts aloud.</a:t>
             </a:r>
           </a:p>
@@ -5208,30 +5181,24 @@
               <a:t>2.1 Reflection: "Think of a time when you personally chose to go beyond compliance and genuinely committed to a strategic direction. What caused that shift? What would it take to create that same shift in your team?"</a:t>
             </a:r>
           </a:p>
-          <a:p>
-            <a:endParaRPr lang="en-GB" dirty="0"/>
-          </a:p>
+          <a:p/>
           <a:p>
             <a:r>
               <a:rPr lang="en-GB" dirty="0"/>
               <a:t>2.2 Reflection: "How much of your current leadership time is spent enforcing compliance? What is the opportunity cost of this?"</a:t>
             </a:r>
           </a:p>
-          <a:p>
-            <a:endParaRPr lang="en-GB" dirty="0"/>
-          </a:p>
+          <a:p/>
           <a:p>
             <a:r>
               <a:rPr lang="en-GB" dirty="0"/>
               <a:t>2.3 Reflection — Installed and adopted: "Name one change in your organisation that is installed and still awaiting adoption. Which check did it fail: Mind, Heart, Hands or Habit? What has the adoption gap cost so far?"</a:t>
             </a:r>
           </a:p>
-          <a:p>
-            <a:endParaRPr lang="en-GB" dirty="0"/>
-          </a:p>
-          <a:p>
-            <a:r>
-              <a:rPr lang="en-GB" b="1" dirty="0"/>
+          <a:p/>
+          <a:p>
+            <a:r>
+              <a:rPr lang="en-GB" dirty="0" b="1"/>
               <a:t>2. Say what the reflections are for.</a:t>
             </a:r>
           </a:p>
@@ -5247,21 +5214,17 @@
               <a:t>The reflections build the learning portfolio they receive at the end of the programme.</a:t>
             </a:r>
           </a:p>
-          <a:p>
-            <a:endParaRPr lang="en-GB" dirty="0"/>
-          </a:p>
+          <a:p/>
           <a:p>
             <a:r>
               <a:rPr lang="en-GB" dirty="0"/>
               <a:t>Say: "You write these reflections on the portal after the teaching, with as much depth as you can."</a:t>
             </a:r>
           </a:p>
-          <a:p>
-            <a:endParaRPr lang="en-GB" dirty="0"/>
-          </a:p>
-          <a:p>
-            <a:r>
-              <a:rPr lang="en-GB" b="1" dirty="0"/>
+          <a:p/>
+          <a:p>
+            <a:r>
+              <a:rPr lang="en-GB" dirty="0" b="1"/>
               <a:t>3. Set the standard.</a:t>
             </a:r>
           </a:p>
@@ -5289,27 +5252,23 @@
               <a:t>Watch for: a cost stated as a feeling. Ask: "What did it cost in rework, supervision or lost benefit?"</a:t>
             </a:r>
           </a:p>
-          <a:p>
-            <a:endParaRPr lang="en-GB" dirty="0"/>
-          </a:p>
-          <a:p>
-            <a:r>
-              <a:rPr lang="en-GB" b="1" dirty="0"/>
-              <a:t>4. Bridge to Section 3.</a:t>
-            </a:r>
-          </a:p>
-          <a:p>
-            <a:r>
-              <a:rPr lang="en-GB" dirty="0"/>
-              <a:t>Say: "We know why alignment decides execution. Section 3 asks where in your organisation it is most at risk."</a:t>
-            </a:r>
-          </a:p>
-          <a:p>
-            <a:endParaRPr lang="en-GB" dirty="0"/>
-          </a:p>
-          <a:p>
-            <a:r>
-              <a:rPr lang="en-GB" b="1" dirty="0"/>
+          <a:p/>
+          <a:p>
+            <a:r>
+              <a:rPr lang="en-GB" dirty="0" b="1"/>
+              <a:t>4. Close Section 2 and bridge to Section 3.</a:t>
+            </a:r>
+          </a:p>
+          <a:p>
+            <a:r>
+              <a:rPr lang="en-GB" dirty="0"/>
+              <a:t>Say: "Execution ignites when people move from compliance to genuine adoption of the change. Section 3 examines where the leadership team stands, through the behavioural profile each member and the team bring to the strategy."</a:t>
+            </a:r>
+          </a:p>
+          <a:p/>
+          <a:p>
+            <a:r>
+              <a:rPr lang="en-GB" dirty="0" b="1"/>
               <a:t>ON THE PORTAL, AFTER THE TEACHING:</a:t>
             </a:r>
           </a:p>
@@ -5386,16 +5345,14 @@
           <a:lstStyle/>
           <a:p>
             <a:r>
-              <a:rPr lang="en-GB" b="1" dirty="0"/>
+              <a:rPr lang="en-GB" dirty="0" b="1"/>
               <a:t>SECTION 3 · EXTRAPOLATING — WHERE</a:t>
             </a:r>
           </a:p>
-          <a:p>
-            <a:endParaRPr lang="en-GB" dirty="0"/>
-          </a:p>
-          <a:p>
-            <a:r>
-              <a:rPr lang="en-GB" b="1" dirty="0"/>
+          <a:p/>
+          <a:p>
+            <a:r>
+              <a:rPr lang="en-GB" dirty="0" b="1"/>
               <a:t>HOW THIS SECTION RUNS:</a:t>
             </a:r>
           </a:p>
@@ -5411,12 +5368,10 @@
               <a:t>2. The Section 3 Reflections slide: the reflection participants write on the portal after the teaching.</a:t>
             </a:r>
           </a:p>
-          <a:p>
-            <a:endParaRPr lang="en-GB" dirty="0"/>
-          </a:p>
-          <a:p>
-            <a:r>
-              <a:rPr lang="en-GB" b="1" dirty="0"/>
+          <a:p/>
+          <a:p>
+            <a:r>
+              <a:rPr lang="en-GB" dirty="0" b="1"/>
               <a:t>SECTION LEARNING OUTCOMES:</a:t>
             </a:r>
           </a:p>
@@ -5432,21 +5387,17 @@
               <a:t>2. Assess change readiness and tailor leadership responses to adoption barriers.</a:t>
             </a:r>
           </a:p>
-          <a:p>
-            <a:endParaRPr lang="en-GB" dirty="0"/>
-          </a:p>
-          <a:p>
-            <a:r>
-              <a:rPr lang="en-GB" b="1" dirty="0"/>
+          <a:p/>
+          <a:p>
+            <a:r>
+              <a:rPr lang="en-GB" dirty="0" b="1"/>
               <a:t>HOW TO OPEN THE SECTION:</a:t>
             </a:r>
           </a:p>
-          <a:p>
-            <a:endParaRPr lang="en-GB" dirty="0"/>
-          </a:p>
-          <a:p>
-            <a:r>
-              <a:rPr lang="en-GB" b="1" dirty="0"/>
+          <a:p/>
+          <a:p>
+            <a:r>
+              <a:rPr lang="en-GB" dirty="0" b="1"/>
               <a:t>1. Say what the section does.</a:t>
             </a:r>
           </a:p>
@@ -5468,12 +5419,10 @@
               <a:t>Your team then sees the profile it brings together."</a:t>
             </a:r>
           </a:p>
-          <a:p>
-            <a:endParaRPr lang="en-GB" dirty="0"/>
-          </a:p>
-          <a:p>
-            <a:r>
-              <a:rPr lang="en-GB" b="1" dirty="0"/>
+          <a:p/>
+          <a:p>
+            <a:r>
+              <a:rPr lang="en-GB" dirty="0" b="1"/>
               <a:t>2. Say how the assessment runs.</a:t>
             </a:r>
           </a:p>
@@ -5486,7 +5435,7 @@
           <a:p>
             <a:r>
               <a:rPr lang="en-GB" dirty="0"/>
-              <a:t>The team’s profile appears in the team’s Capstone Blueprint once every member has submitted.</a:t>
+              <a:t>The team’s profile appears in the team’s Capstone S2R® Blueprint once every member has submitted.</a:t>
             </a:r>
           </a:p>
         </p:txBody>
@@ -5572,869 +5521,264 @@
           <a:lstStyle/>
           <a:p>
             <a:r>
-              <a:rPr lang="en-GB" b="1" dirty="0"/>
+              <a:rPr lang="en-GB" dirty="0" b="1"/>
               <a:t>3.1 — THE OCEAVL ASSESSMENT: PERSONAL AND TEAM BEHAVIOURAL PROFILE (SEVEN DIMENSIONS) · THE SEVEN DIMENSIONS</a:t>
             </a:r>
           </a:p>
-          <a:p>
-            <a:endParaRPr lang="en-GB" dirty="0"/>
-          </a:p>
-          <a:p>
-            <a:r>
-              <a:rPr lang="en-GB" b="1" dirty="0"/>
+          <a:p/>
+          <a:p>
+            <a:r>
+              <a:rPr lang="en-GB" dirty="0" b="1"/>
               <a:t>HOW TO TEACH IT:</a:t>
             </a:r>
           </a:p>
-          <a:p>
-            <a:endParaRPr lang="en-GB" dirty="0"/>
-          </a:p>
-          <a:p>
-            <a:r>
-              <a:rPr lang="en-ZA" b="1" dirty="0"/>
-              <a:t>Link The Assessment To Principle 3</a:t>
-            </a:r>
-            <a:endParaRPr lang="en-ZA" dirty="0"/>
-          </a:p>
-          <a:p>
-            <a:r>
-              <a:rPr lang="en-ZA" b="1" dirty="0"/>
-              <a:t>Say:</a:t>
-            </a:r>
-          </a:p>
-          <a:p>
-            <a:r>
-              <a:rPr lang="en-ZA" dirty="0"/>
-              <a:t>“Principle 3 established that alignment must be designed.</a:t>
-            </a:r>
-          </a:p>
-          <a:p>
-            <a:r>
-              <a:rPr lang="en-ZA" dirty="0"/>
-              <a:t>One way to design alignment is to understand the human tendencies that shape how leaders read strategy, handle disagreement, make decisions and respond under pressure.</a:t>
-            </a:r>
-          </a:p>
-          <a:p>
-            <a:endParaRPr lang="en-ZA" dirty="0"/>
-          </a:p>
-          <a:p>
-            <a:r>
-              <a:rPr lang="en-ZA" dirty="0"/>
-              <a:t>For this programme, we use the OCEAVL Assessment.</a:t>
-            </a:r>
-          </a:p>
-          <a:p>
-            <a:r>
-              <a:rPr lang="en-ZA" dirty="0"/>
-              <a:t>OCEAVL is adapted from the Big Five personality model. We use it here as a strategy execution tool.</a:t>
-            </a:r>
-          </a:p>
-          <a:p>
-            <a:endParaRPr lang="en-ZA" dirty="0"/>
-          </a:p>
-          <a:p>
-            <a:r>
-              <a:rPr lang="en-ZA" dirty="0"/>
-              <a:t>The assessment surfaces seven psychological tendencies that may influence executive decision-making and team coherence.</a:t>
-            </a:r>
-          </a:p>
-          <a:p>
-            <a:r>
-              <a:rPr lang="en-ZA" dirty="0"/>
-              <a:t>It gives each leader a profile across seven dimensions. </a:t>
-            </a:r>
-          </a:p>
-          <a:p>
-            <a:r>
-              <a:rPr lang="en-ZA" dirty="0"/>
-              <a:t>For each dimension, the tool shows whether the tendency is expressed at a low, balanced or high level.</a:t>
-            </a:r>
-          </a:p>
-          <a:p>
-            <a:endParaRPr lang="en-ZA" dirty="0"/>
-          </a:p>
-          <a:p>
-            <a:r>
-              <a:rPr lang="en-ZA" dirty="0"/>
-              <a:t>Each level then gives three things:</a:t>
-            </a:r>
-          </a:p>
-          <a:p>
-            <a:pPr marL="228600" lvl="0" indent="-228600">
-              <a:buFont typeface="+mj-lt"/>
-              <a:buAutoNum type="arabicPeriod"/>
-            </a:pPr>
-            <a:r>
-              <a:rPr lang="en-ZA" dirty="0"/>
-              <a:t>The risk this disposition may create for strategy execution.</a:t>
-            </a:r>
-          </a:p>
-          <a:p>
-            <a:pPr marL="228600" lvl="0" indent="-228600">
-              <a:buFont typeface="+mj-lt"/>
-              <a:buAutoNum type="arabicPeriod"/>
-            </a:pPr>
-            <a:r>
-              <a:rPr lang="en-ZA" dirty="0"/>
-              <a:t>The response required to manage the risk.</a:t>
-            </a:r>
-          </a:p>
-          <a:p>
-            <a:pPr marL="228600" lvl="0" indent="-228600">
-              <a:buFont typeface="+mj-lt"/>
-              <a:buAutoNum type="arabicPeriod"/>
-            </a:pPr>
-            <a:r>
-              <a:rPr lang="en-ZA" dirty="0"/>
-              <a:t>The routine that turns the response into repeated leadership practice.”</a:t>
-            </a:r>
-          </a:p>
-          <a:p>
-            <a:endParaRPr lang="en-ZA" dirty="0"/>
-          </a:p>
-          <a:p>
-            <a:r>
-              <a:rPr lang="en-ZA" dirty="0"/>
-              <a:t>Then add:</a:t>
-            </a:r>
-          </a:p>
-          <a:p>
-            <a:r>
-              <a:rPr lang="en-ZA" dirty="0"/>
-              <a:t>“The value of the tool is not the score. The value is the insight. </a:t>
-            </a:r>
-          </a:p>
-          <a:p>
-            <a:r>
-              <a:rPr lang="en-ZA" dirty="0"/>
-              <a:t>It helps us see how our personal disposition may be helping or hurting alignment before the strategy reaches execution.”</a:t>
-            </a:r>
-          </a:p>
-          <a:p>
-            <a:endParaRPr lang="en-ZA" b="1" dirty="0"/>
-          </a:p>
-          <a:p>
-            <a:r>
-              <a:rPr lang="en-ZA" b="1" dirty="0"/>
-              <a:t>Explain How To Read The Tool</a:t>
-            </a:r>
-            <a:endParaRPr lang="en-ZA" dirty="0"/>
-          </a:p>
-          <a:p>
-            <a:r>
-              <a:rPr lang="en-ZA" b="1" dirty="0"/>
-              <a:t>Say:</a:t>
-            </a:r>
-          </a:p>
-          <a:p>
-            <a:r>
-              <a:rPr lang="en-ZA" dirty="0"/>
-              <a:t>“When you read your profile, read it as a map of how the team tends to respond.</a:t>
-            </a:r>
-          </a:p>
-          <a:p>
-            <a:r>
-              <a:rPr lang="en-ZA" dirty="0"/>
-              <a:t>The tool is asking four simple questions:</a:t>
-            </a:r>
-          </a:p>
-          <a:p>
-            <a:pPr marL="228600" lvl="0" indent="-228600">
-              <a:buFont typeface="+mj-lt"/>
-              <a:buAutoNum type="arabicPeriod"/>
-            </a:pPr>
-            <a:r>
-              <a:rPr lang="en-ZA" dirty="0"/>
-              <a:t>What tendency is showing up?</a:t>
-            </a:r>
-          </a:p>
-          <a:p>
-            <a:pPr marL="228600" lvl="0" indent="-228600">
-              <a:buFont typeface="+mj-lt"/>
-              <a:buAutoNum type="arabicPeriod"/>
-            </a:pPr>
-            <a:r>
-              <a:rPr lang="en-ZA" dirty="0"/>
-              <a:t>At what level is it showing up? Low, balanced or high</a:t>
-            </a:r>
-          </a:p>
-          <a:p>
-            <a:pPr marL="228600" lvl="0" indent="-228600">
-              <a:buFont typeface="+mj-lt"/>
-              <a:buAutoNum type="arabicPeriod"/>
-            </a:pPr>
-            <a:r>
-              <a:rPr lang="en-ZA" dirty="0"/>
-              <a:t>What risk could this create for strategy execution?</a:t>
-            </a:r>
-          </a:p>
-          <a:p>
-            <a:pPr marL="228600" lvl="0" indent="-228600">
-              <a:buFont typeface="+mj-lt"/>
-              <a:buAutoNum type="arabicPeriod"/>
-            </a:pPr>
-            <a:r>
-              <a:rPr lang="en-ZA" dirty="0"/>
-              <a:t>What routine can help us manage that risk?”</a:t>
-            </a:r>
-          </a:p>
-          <a:p>
-            <a:endParaRPr lang="en-ZA" dirty="0"/>
-          </a:p>
-          <a:p>
-            <a:r>
-              <a:rPr lang="en-ZA" b="1" dirty="0"/>
-              <a:t>Then explain:</a:t>
-            </a:r>
-          </a:p>
-          <a:p>
-            <a:r>
-              <a:rPr lang="en-ZA" dirty="0"/>
-              <a:t>“A low level is not automatically bad. </a:t>
-            </a:r>
-          </a:p>
-          <a:p>
-            <a:r>
-              <a:rPr lang="en-ZA" dirty="0"/>
-              <a:t>A high level is not automatically good. </a:t>
-            </a:r>
-          </a:p>
-          <a:p>
-            <a:r>
-              <a:rPr lang="en-ZA" dirty="0"/>
-              <a:t>A balanced level is not automatically safe.</a:t>
-            </a:r>
-          </a:p>
-          <a:p>
-            <a:endParaRPr lang="en-ZA" dirty="0"/>
-          </a:p>
-          <a:p>
-            <a:r>
-              <a:rPr lang="en-ZA" dirty="0"/>
-              <a:t>Every level has a contribution. Every level also has a possible risk.</a:t>
-            </a:r>
-          </a:p>
-          <a:p>
-            <a:r>
-              <a:rPr lang="en-ZA" dirty="0"/>
-              <a:t>The question is: what does this strategy require from us now?”</a:t>
-            </a:r>
-          </a:p>
-          <a:p>
-            <a:endParaRPr lang="en-ZA" b="1" dirty="0"/>
-          </a:p>
-          <a:p>
-            <a:r>
-              <a:rPr lang="en-ZA" b="1" dirty="0"/>
-              <a:t>Say How Each Participant Completes It</a:t>
-            </a:r>
-            <a:endParaRPr lang="en-ZA" dirty="0"/>
-          </a:p>
-          <a:p>
-            <a:r>
-              <a:rPr lang="en-ZA" b="1" dirty="0"/>
-              <a:t>Say:</a:t>
-            </a:r>
-          </a:p>
-          <a:p>
-            <a:r>
-              <a:rPr lang="en-ZA" dirty="0"/>
-              <a:t>“You will complete the assessment alone, on your own page.</a:t>
-            </a:r>
-          </a:p>
-          <a:p>
-            <a:r>
-              <a:rPr lang="en-ZA" dirty="0"/>
-              <a:t>You will score yourself from 1 to 5 on each of the seven dimensions.</a:t>
-            </a:r>
-          </a:p>
-          <a:p>
-            <a:r>
-              <a:rPr lang="en-ZA" dirty="0"/>
-              <a:t>After that, you will read your own profile. Your profile will show your level for each dimension, the possible risk, the response and the suggested routine.</a:t>
-            </a:r>
-          </a:p>
-          <a:p>
-            <a:r>
-              <a:rPr lang="en-ZA" dirty="0"/>
-              <a:t>You will then select </a:t>
-            </a:r>
-            <a:r>
-              <a:rPr lang="en-ZA" b="1" dirty="0"/>
-              <a:t>Submit to My Team’s Capstone</a:t>
-            </a:r>
-            <a:r>
-              <a:rPr lang="en-ZA" dirty="0"/>
-              <a:t>.”</a:t>
-            </a:r>
-          </a:p>
-          <a:p>
-            <a:endParaRPr lang="en-ZA" dirty="0"/>
-          </a:p>
-          <a:p>
-            <a:r>
-              <a:rPr lang="en-ZA" b="1" dirty="0"/>
-              <a:t>Add:</a:t>
-            </a:r>
-          </a:p>
-          <a:p>
-            <a:r>
-              <a:rPr lang="en-ZA" dirty="0"/>
-              <a:t>“This is personal reflection first. </a:t>
-            </a:r>
-          </a:p>
-          <a:p>
-            <a:r>
-              <a:rPr lang="en-ZA" dirty="0"/>
-              <a:t>Do not rush to compare yourself with others. </a:t>
-            </a:r>
-          </a:p>
-          <a:p>
-            <a:r>
-              <a:rPr lang="en-ZA" dirty="0"/>
-              <a:t>First ask: what does this reveal about how I read and lead strategy?”</a:t>
-            </a:r>
-          </a:p>
-          <a:p>
-            <a:endParaRPr lang="en-ZA" b="1" dirty="0"/>
-          </a:p>
-          <a:p>
-            <a:r>
-              <a:rPr lang="en-ZA" b="1" dirty="0"/>
-              <a:t>Say What The Team Sees</a:t>
-            </a:r>
-            <a:endParaRPr lang="en-ZA" dirty="0"/>
-          </a:p>
-          <a:p>
-            <a:r>
-              <a:rPr lang="en-ZA" b="1" dirty="0"/>
-              <a:t>Say:</a:t>
-            </a:r>
-          </a:p>
-          <a:p>
-            <a:r>
-              <a:rPr lang="en-ZA" dirty="0"/>
-              <a:t>“Your team does not see individual names or single personal scores.</a:t>
-            </a:r>
-          </a:p>
-          <a:p>
-            <a:r>
-              <a:rPr lang="en-ZA" dirty="0"/>
-              <a:t>The team sees the team’s overall level on each dimension and the count at each level.</a:t>
-            </a:r>
-          </a:p>
-          <a:p>
-            <a:r>
-              <a:rPr lang="en-ZA" dirty="0"/>
-              <a:t>This allows the team to discuss its collective behavioural pattern without exposing individual profiles.”</a:t>
-            </a:r>
-          </a:p>
-          <a:p>
-            <a:endParaRPr lang="en-ZA" dirty="0"/>
-          </a:p>
-          <a:p>
-            <a:r>
-              <a:rPr lang="en-ZA" b="1" dirty="0"/>
-              <a:t>Then add:</a:t>
-            </a:r>
-          </a:p>
-          <a:p>
-            <a:r>
-              <a:rPr lang="en-ZA" dirty="0"/>
-              <a:t>“The team discussion is not about who scored what. It is about what the collective pattern could mean for the strategy.”</a:t>
-            </a:r>
-          </a:p>
-          <a:p>
-            <a:endParaRPr lang="en-ZA" b="1" dirty="0"/>
-          </a:p>
-          <a:p>
-            <a:r>
-              <a:rPr lang="en-ZA" b="1" dirty="0"/>
-              <a:t>Walk The Seven Dimensions On The Slide</a:t>
-            </a:r>
-            <a:endParaRPr lang="en-ZA" dirty="0"/>
-          </a:p>
-          <a:p>
-            <a:r>
-              <a:rPr lang="en-ZA" b="1" dirty="0"/>
-              <a:t>Say:</a:t>
-            </a:r>
-          </a:p>
-          <a:p>
-            <a:r>
-              <a:rPr lang="en-ZA" dirty="0"/>
-              <a:t>“These are the seven dimensions we are assessing. Each one tells us something about how leaders carry strategy.”</a:t>
-            </a:r>
-          </a:p>
-          <a:p>
-            <a:endParaRPr lang="en-ZA" b="1" dirty="0"/>
-          </a:p>
-          <a:p>
-            <a:r>
-              <a:rPr lang="en-ZA" b="1" dirty="0"/>
-              <a:t>1. Openness</a:t>
-            </a:r>
-            <a:endParaRPr lang="en-ZA" dirty="0"/>
-          </a:p>
-          <a:p>
-            <a:r>
-              <a:rPr lang="en-ZA" dirty="0"/>
-              <a:t>“Openness is about curiosity, creativity and adaptability to new approaches.</a:t>
-            </a:r>
-          </a:p>
-          <a:p>
-            <a:r>
-              <a:rPr lang="en-ZA" dirty="0"/>
-              <a:t>It shows how willing a leader is to consider new ideas, question old assumptions and respond to change.</a:t>
-            </a:r>
-          </a:p>
-          <a:p>
-            <a:r>
-              <a:rPr lang="en-ZA" dirty="0"/>
-              <a:t>In strategy, openness matters because the environment keeps changing. </a:t>
-            </a:r>
-          </a:p>
-          <a:p>
-            <a:r>
-              <a:rPr lang="en-ZA" dirty="0"/>
-              <a:t>A team with too little openness may stay too attached to familiar ways. </a:t>
-            </a:r>
-          </a:p>
-          <a:p>
-            <a:r>
-              <a:rPr lang="en-ZA" dirty="0"/>
-              <a:t>A team with too much openness may chase too many ideas at once.”</a:t>
-            </a:r>
-          </a:p>
-          <a:p>
-            <a:endParaRPr lang="en-ZA" b="1" dirty="0"/>
-          </a:p>
-          <a:p>
-            <a:r>
-              <a:rPr lang="en-ZA" b="1" dirty="0"/>
-              <a:t>2. Conscientiousness</a:t>
-            </a:r>
-            <a:endParaRPr lang="en-ZA" dirty="0"/>
-          </a:p>
-          <a:p>
-            <a:r>
-              <a:rPr lang="en-ZA" dirty="0"/>
-              <a:t>“Conscientiousness is about discipline, planning and follow-through on commitments.</a:t>
-            </a:r>
-          </a:p>
-          <a:p>
-            <a:r>
-              <a:rPr lang="en-ZA" dirty="0"/>
-              <a:t>It shows how reliably a leader organises work, tracks commitments and completes what has been agreed.</a:t>
-            </a:r>
-          </a:p>
-          <a:p>
-            <a:r>
-              <a:rPr lang="en-ZA" dirty="0"/>
-              <a:t>In strategy, conscientiousness matters because execution needs structure. </a:t>
-            </a:r>
-          </a:p>
-          <a:p>
-            <a:r>
-              <a:rPr lang="en-ZA" dirty="0"/>
-              <a:t>Without discipline, strategy remains a statement. </a:t>
-            </a:r>
-          </a:p>
-          <a:p>
-            <a:r>
-              <a:rPr lang="en-ZA" dirty="0"/>
-              <a:t>With discipline, strategy becomes action, ownership and review.”</a:t>
-            </a:r>
-          </a:p>
-          <a:p>
-            <a:endParaRPr lang="en-ZA" b="1" dirty="0"/>
-          </a:p>
-          <a:p>
-            <a:r>
-              <a:rPr lang="en-ZA" b="1" dirty="0"/>
-              <a:t>3. Extraversion</a:t>
-            </a:r>
-            <a:endParaRPr lang="en-ZA" dirty="0"/>
-          </a:p>
-          <a:p>
-            <a:r>
-              <a:rPr lang="en-ZA" dirty="0"/>
-              <a:t>“Extraversion is about outward energy, communication and comfort with collaboration.</a:t>
-            </a:r>
-          </a:p>
-          <a:p>
-            <a:r>
-              <a:rPr lang="en-ZA" dirty="0"/>
-              <a:t>It shows how easily a leader engages others, speaks into the room and helps move energy through the team.</a:t>
-            </a:r>
-          </a:p>
-          <a:p>
-            <a:r>
-              <a:rPr lang="en-ZA" dirty="0"/>
-              <a:t>In strategy, extraversion matters because strategy must be communicated. </a:t>
-            </a:r>
-          </a:p>
-          <a:p>
-            <a:r>
-              <a:rPr lang="en-ZA" dirty="0"/>
-              <a:t>People do not align to a document alone. They align through conversation, explanation and leadership signals.”</a:t>
-            </a:r>
-          </a:p>
-          <a:p>
-            <a:endParaRPr lang="en-ZA" b="1" dirty="0"/>
-          </a:p>
-          <a:p>
-            <a:r>
-              <a:rPr lang="en-ZA" b="1" dirty="0"/>
-              <a:t>4. Agreeableness</a:t>
-            </a:r>
-            <a:endParaRPr lang="en-ZA" dirty="0"/>
-          </a:p>
-          <a:p>
-            <a:r>
-              <a:rPr lang="en-ZA" dirty="0"/>
-              <a:t>“Agreeableness is about harmony, conflict management and cooperation.</a:t>
-            </a:r>
-          </a:p>
-          <a:p>
-            <a:r>
-              <a:rPr lang="en-ZA" dirty="0"/>
-              <a:t>It shows how a leader works with others, handles tension and protects relationships.</a:t>
-            </a:r>
-          </a:p>
-          <a:p>
-            <a:r>
-              <a:rPr lang="en-ZA" dirty="0"/>
-              <a:t>In strategy, agreeableness matters because execution depends on trust and cooperation. </a:t>
-            </a:r>
-          </a:p>
-          <a:p>
-            <a:r>
-              <a:rPr lang="en-ZA" dirty="0"/>
-              <a:t>But harmony must not replace honesty. A team can agree politely and still avoid the difficult issue.”</a:t>
-            </a:r>
-          </a:p>
-          <a:p>
-            <a:endParaRPr lang="en-ZA" b="1" dirty="0"/>
-          </a:p>
-          <a:p>
-            <a:r>
-              <a:rPr lang="en-ZA" b="1" dirty="0"/>
-              <a:t>5. Emotional Stability</a:t>
-            </a:r>
-            <a:endParaRPr lang="en-ZA" dirty="0"/>
-          </a:p>
-          <a:p>
-            <a:r>
-              <a:rPr lang="en-ZA" dirty="0"/>
-              <a:t>“Emotional Stability is about composure under pressure and emotional resilience.</a:t>
-            </a:r>
-          </a:p>
-          <a:p>
-            <a:r>
-              <a:rPr lang="en-ZA" dirty="0"/>
-              <a:t>It shows how a leader behaves when there is stress, criticism, uncertainty or failure.</a:t>
-            </a:r>
-          </a:p>
-          <a:p>
-            <a:r>
-              <a:rPr lang="en-ZA" dirty="0"/>
-              <a:t>In strategy, emotional stability matters because execution always brings pressure.</a:t>
-            </a:r>
-          </a:p>
-          <a:p>
-            <a:r>
-              <a:rPr lang="en-ZA" dirty="0"/>
-              <a:t>If leaders become reactive, the team spends its energy managing emotions, and the strategy waits.”</a:t>
-            </a:r>
-          </a:p>
-          <a:p>
-            <a:endParaRPr lang="en-ZA" b="1" dirty="0"/>
-          </a:p>
-          <a:p>
-            <a:r>
-              <a:rPr lang="en-ZA" b="1" dirty="0"/>
-              <a:t>6. Values Alignment</a:t>
-            </a:r>
-            <a:endParaRPr lang="en-ZA" dirty="0"/>
-          </a:p>
-          <a:p>
-            <a:r>
-              <a:rPr lang="en-ZA" dirty="0"/>
-              <a:t>“Values Alignment is about consistency between stated values and lived behaviour.</a:t>
-            </a:r>
-          </a:p>
-          <a:p>
-            <a:r>
-              <a:rPr lang="en-ZA" dirty="0"/>
-              <a:t>It shows whether a leader’s choices, actions and trade-offs match what the organisation says it stands for.</a:t>
-            </a:r>
-          </a:p>
-          <a:p>
-            <a:r>
-              <a:rPr lang="en-ZA" dirty="0"/>
-              <a:t>In strategy, values alignment matters because people watch behaviour more than slogans. </a:t>
-            </a:r>
-          </a:p>
-          <a:p>
-            <a:r>
-              <a:rPr lang="en-ZA" dirty="0"/>
-              <a:t>When values and decisions match, trust grows. When they do not match, people comply and commitment weakens.”</a:t>
-            </a:r>
-          </a:p>
-          <a:p>
-            <a:endParaRPr lang="en-ZA" b="1" dirty="0"/>
-          </a:p>
-          <a:p>
-            <a:r>
-              <a:rPr lang="en-ZA" b="1" dirty="0"/>
-              <a:t>7. Learning Orientation</a:t>
-            </a:r>
-            <a:endParaRPr lang="en-ZA" dirty="0"/>
-          </a:p>
-          <a:p>
-            <a:r>
-              <a:rPr lang="en-ZA" dirty="0"/>
-              <a:t>“Learning Orientation is about growth mindset, openness to feedback and skill development.</a:t>
-            </a:r>
-          </a:p>
-          <a:p>
-            <a:r>
-              <a:rPr lang="en-ZA" dirty="0"/>
-              <a:t>It shows whether a leader can learn, adapt and improve through experience.</a:t>
-            </a:r>
-          </a:p>
-          <a:p>
-            <a:r>
-              <a:rPr lang="en-ZA" dirty="0"/>
-              <a:t>In strategy, learning orientation matters because strategy is iterative. </a:t>
-            </a:r>
-          </a:p>
-          <a:p>
-            <a:r>
-              <a:rPr lang="en-ZA" dirty="0"/>
-              <a:t>We decide, test, learn and refine. A team that cannot learn will keep defending old choices even when reality has changed.”</a:t>
-            </a:r>
-          </a:p>
-          <a:p>
-            <a:endParaRPr lang="en-ZA" b="1" dirty="0"/>
-          </a:p>
-          <a:p>
-            <a:r>
-              <a:rPr lang="en-ZA" b="1" dirty="0"/>
-              <a:t>Explain The Three Levels Of Disposition</a:t>
-            </a:r>
-            <a:endParaRPr lang="en-ZA" dirty="0"/>
-          </a:p>
-          <a:p>
-            <a:r>
-              <a:rPr lang="en-ZA" b="1" dirty="0"/>
-              <a:t>Say:</a:t>
-            </a:r>
-          </a:p>
-          <a:p>
-            <a:r>
-              <a:rPr lang="en-ZA" dirty="0"/>
-              <a:t>“For each dimension, the tool reads the tendency at three levels: Low, Balanced and High.</a:t>
-            </a:r>
-          </a:p>
-          <a:p>
-            <a:r>
-              <a:rPr lang="en-ZA" dirty="0"/>
-              <a:t>Low means the tendency is less visible or less naturally used.</a:t>
-            </a:r>
-          </a:p>
-          <a:p>
-            <a:r>
-              <a:rPr lang="en-ZA" dirty="0"/>
-              <a:t>Balanced means the tendency is present in a moderate way.</a:t>
-            </a:r>
-          </a:p>
-          <a:p>
-            <a:r>
-              <a:rPr lang="en-ZA" dirty="0"/>
-              <a:t>High means the tendency is strongly visible.</a:t>
-            </a:r>
-          </a:p>
-          <a:p>
-            <a:endParaRPr lang="en-ZA" dirty="0"/>
-          </a:p>
-          <a:p>
-            <a:r>
-              <a:rPr lang="en-ZA" dirty="0"/>
-              <a:t>None of these levels is automatically good or bad. </a:t>
-            </a:r>
-          </a:p>
-          <a:p>
-            <a:r>
-              <a:rPr lang="en-ZA" dirty="0"/>
-              <a:t>The level becomes useful or risky depending on the strategy being carried.”</a:t>
-            </a:r>
-          </a:p>
-          <a:p>
-            <a:endParaRPr lang="en-ZA" dirty="0"/>
-          </a:p>
-          <a:p>
-            <a:r>
-              <a:rPr lang="en-ZA" dirty="0"/>
-              <a:t>Then add:</a:t>
-            </a:r>
-          </a:p>
-          <a:p>
-            <a:r>
-              <a:rPr lang="en-ZA" dirty="0"/>
-              <a:t>“For example, high openness may help innovation, but it may also create too many ideas. Low openness may protect stability, but it may also delay adaptation. Balanced openness may support careful experimentation, but it may still avoid uncomfortable change.”</a:t>
-            </a:r>
-          </a:p>
-          <a:p>
-            <a:endParaRPr lang="en-ZA" b="1" dirty="0"/>
-          </a:p>
-          <a:p>
-            <a:r>
-              <a:rPr lang="en-ZA" b="1" dirty="0"/>
-              <a:t>Use One Worked Example</a:t>
-            </a:r>
-            <a:endParaRPr lang="en-ZA" dirty="0"/>
-          </a:p>
-          <a:p>
-            <a:r>
-              <a:rPr lang="en-ZA" b="1" dirty="0"/>
-              <a:t>Say:</a:t>
-            </a:r>
-          </a:p>
-          <a:p>
-            <a:r>
-              <a:rPr lang="en-ZA" dirty="0"/>
-              <a:t>“Let us take one example so that you can see how the tool works.”</a:t>
-            </a:r>
-          </a:p>
-          <a:p>
-            <a:r>
-              <a:rPr lang="en-ZA" b="1" dirty="0"/>
-              <a:t>Example: High Agreeableness</a:t>
-            </a:r>
-            <a:endParaRPr lang="en-ZA" dirty="0"/>
-          </a:p>
-          <a:p>
-            <a:r>
-              <a:rPr lang="en-ZA" dirty="0"/>
-              <a:t>“High agreeableness means the leader is kind, warm, cooperative and ready to help.</a:t>
-            </a:r>
-          </a:p>
-          <a:p>
-            <a:r>
-              <a:rPr lang="en-ZA" dirty="0"/>
-              <a:t>This is a strength because it builds trust. People feel supported and respected.</a:t>
-            </a:r>
-          </a:p>
-          <a:p>
-            <a:r>
-              <a:rPr lang="en-ZA" dirty="0"/>
-              <a:t>But the risk is that agreement may be given without real commitment. People may avoid saying no. The team may over-commit because nobody wants to disappoint others. Resentment may build under the surface.”</a:t>
-            </a:r>
-          </a:p>
-          <a:p>
-            <a:endParaRPr lang="en-ZA" dirty="0"/>
-          </a:p>
-          <a:p>
-            <a:r>
-              <a:rPr lang="en-ZA" b="1" dirty="0"/>
-              <a:t>Say:</a:t>
-            </a:r>
-          </a:p>
-          <a:p>
-            <a:r>
-              <a:rPr lang="en-ZA" dirty="0"/>
-              <a:t>“The response is to create a formal challenge role. Someone must be allowed to ask the difficult question without being seen as negative.”</a:t>
-            </a:r>
-          </a:p>
-          <a:p>
-            <a:endParaRPr lang="en-ZA" dirty="0"/>
-          </a:p>
-          <a:p>
-            <a:r>
-              <a:rPr lang="en-ZA" b="1" dirty="0"/>
-              <a:t>Say:</a:t>
-            </a:r>
-          </a:p>
-          <a:p>
-            <a:r>
-              <a:rPr lang="en-ZA" dirty="0"/>
-              <a:t>“The routine is the Rotating Challenger. In each major discussion, one person is assigned to challenge assumptions, name risks and ask what the team may be avoiding.”</a:t>
-            </a:r>
-          </a:p>
-          <a:p>
-            <a:endParaRPr lang="en-ZA" dirty="0"/>
-          </a:p>
-          <a:p>
-            <a:r>
-              <a:rPr lang="en-ZA" dirty="0"/>
-              <a:t>Then connect to S2R®:</a:t>
-            </a:r>
-          </a:p>
-          <a:p>
-            <a:r>
-              <a:rPr lang="en-ZA" dirty="0"/>
-              <a:t>“In Strategy2Results®, this protects alignment. It helps the team move from polite agreement to real commitment.”</a:t>
-            </a:r>
-          </a:p>
-          <a:p>
-            <a:endParaRPr lang="en-ZA" b="1" dirty="0"/>
-          </a:p>
-          <a:p>
-            <a:r>
-              <a:rPr lang="en-ZA" b="1" dirty="0"/>
-              <a:t>Refer Participants To The Portal</a:t>
-            </a:r>
-            <a:endParaRPr lang="en-ZA" dirty="0"/>
-          </a:p>
-          <a:p>
-            <a:r>
-              <a:rPr lang="en-ZA" dirty="0"/>
-              <a:t>Say:</a:t>
-            </a:r>
-          </a:p>
-          <a:p>
-            <a:r>
-              <a:rPr lang="en-ZA" dirty="0"/>
-              <a:t>“We will not teach every risk, response and routine in class. The full detail is in the portal.</a:t>
-            </a:r>
-          </a:p>
-          <a:p>
-            <a:r>
-              <a:rPr lang="en-ZA" dirty="0"/>
-              <a:t>In the portal, you will find all seven dimensions. For each one, you will see the low, balanced and high levels, with the matching risk, response and routine.</a:t>
-            </a:r>
-          </a:p>
-          <a:p>
-            <a:r>
-              <a:rPr lang="en-ZA" dirty="0"/>
-              <a:t>Your task is to complete the assessment, read your personal profile and then reflect on the disposition that may carry the highest risk for how you read and lead strategy.”</a:t>
-            </a:r>
-          </a:p>
-          <a:p>
-            <a:endParaRPr lang="en-ZA" b="1" dirty="0"/>
-          </a:p>
-          <a:p>
-            <a:r>
-              <a:rPr lang="en-ZA" b="1" dirty="0"/>
-              <a:t>Close</a:t>
-            </a:r>
-            <a:endParaRPr lang="en-ZA" dirty="0"/>
-          </a:p>
-          <a:p>
-            <a:r>
-              <a:rPr lang="en-ZA" dirty="0"/>
-              <a:t>Say:</a:t>
-            </a:r>
-          </a:p>
-          <a:p>
-            <a:r>
-              <a:rPr lang="en-ZA" dirty="0"/>
-              <a:t>“OCEAVL helps us see the human pattern behind strategy execution. Once we can see the pattern, we can design the right guardrails. That is how alignment is designed.”</a:t>
-            </a:r>
-          </a:p>
-          <a:p>
-            <a:endParaRPr lang="en-GB" dirty="0"/>
+          <a:p/>
+          <a:p>
+            <a:r>
+              <a:rPr lang="en-GB" dirty="0" b="1"/>
+              <a:t>1. Link the assessment to Principle 3.</a:t>
+            </a:r>
+          </a:p>
+          <a:p>
+            <a:r>
+              <a:rPr lang="en-GB" dirty="0"/>
+              <a:t>Say: "Principle 3 established that alignment must be designed. One way to design alignment is to understand the human tendencies that shape how leaders read strategy, handle disagreement, make decisions and respond under pressure."</a:t>
+            </a:r>
+          </a:p>
+          <a:p>
+            <a:r>
+              <a:rPr lang="en-GB" dirty="0"/>
+              <a:t>Say: "For this programme we use the OCEAVL Assessment. OCEAVL is adapted from the Big Five personality model, and we use it here as a strategy execution tool. It surfaces seven psychological tendencies that may influence executive decision-making and team coherence. It gives each leader a profile across seven dimensions, and for each dimension it shows whether the tendency is expressed at a low, balanced or high level."</a:t>
+            </a:r>
+          </a:p>
+          <a:p>
+            <a:r>
+              <a:rPr lang="en-GB" dirty="0"/>
+              <a:t>Say: "Each level then gives three things: the risk this disposition may create for strategy execution, the response required to manage the risk, and the routine that turns the response into repeated leadership practice."</a:t>
+            </a:r>
+          </a:p>
+          <a:p>
+            <a:r>
+              <a:rPr lang="en-GB" dirty="0"/>
+              <a:t>Say: "The value of the tool lies in the insight it gives. It helps us see how our personal disposition may be helping or hurting alignment before the strategy reaches execution."</a:t>
+            </a:r>
+          </a:p>
+          <a:p/>
+          <a:p>
+            <a:r>
+              <a:rPr lang="en-GB" dirty="0" b="1"/>
+              <a:t>2. Explain how to read the tool.</a:t>
+            </a:r>
+          </a:p>
+          <a:p>
+            <a:r>
+              <a:rPr lang="en-GB" dirty="0"/>
+              <a:t>Say: "When you read a profile, read it as a map of how you tend to respond. The tool asks four simple questions. What tendency is showing up? At what level is it showing up: low, balanced or high? What risk could this create for strategy execution? What routine can help us manage that risk?"</a:t>
+            </a:r>
+          </a:p>
+          <a:p/>
+          <a:p>
+            <a:r>
+              <a:rPr lang="en-GB" dirty="0" b="1"/>
+              <a:t>3. Walk the seven dimensions on the slide.</a:t>
+            </a:r>
+          </a:p>
+          <a:p>
+            <a:r>
+              <a:rPr lang="en-GB" dirty="0"/>
+              <a:t>Say: "These are the seven dimensions we assess. Each one tells us something about how leaders carry strategy."</a:t>
+            </a:r>
+          </a:p>
+          <a:p>
+            <a:r>
+              <a:rPr lang="en-GB" dirty="0"/>
+              <a:t>Openness. Say: "Openness is about curiosity, creativity and adaptability to new approaches. It shows how willing a leader is to consider new ideas, question old assumptions and respond to change. In strategy, openness matters because the environment keeps changing. A team with too little openness may stay too attached to familiar ways. A team with too much openness may chase too many ideas at once."</a:t>
+            </a:r>
+          </a:p>
+          <a:p>
+            <a:r>
+              <a:rPr lang="en-GB" dirty="0"/>
+              <a:t>Conscientiousness. Say: "Conscientiousness is about discipline, planning and follow-through on commitments. It shows how reliably a leader organises work, tracks commitments and completes what has been agreed. In strategy, conscientiousness matters because execution needs structure. Without discipline, strategy remains a statement. With discipline, strategy becomes action, ownership and review."</a:t>
+            </a:r>
+          </a:p>
+          <a:p>
+            <a:r>
+              <a:rPr lang="en-GB" dirty="0"/>
+              <a:t>Extraversion. Say: "Extraversion is about outward energy, communication and comfort with collaboration. It shows how easily a leader engages others, speaks into the room and helps move energy through the team. In strategy, extraversion matters because strategy must be communicated. People align through conversation, explanation and leadership signals, and a document alone moves no one."</a:t>
+            </a:r>
+          </a:p>
+          <a:p>
+            <a:r>
+              <a:rPr lang="en-GB" dirty="0"/>
+              <a:t>Agreeableness. Say: "Agreeableness is about harmony, conflict management and cooperation. It shows how a leader works with others, handles tension and protects relationships. In strategy, agreeableness matters because execution depends on trust and cooperation. Harmony must still leave room for honesty. A team can agree politely and still avoid the difficult issue."</a:t>
+            </a:r>
+          </a:p>
+          <a:p>
+            <a:r>
+              <a:rPr lang="en-GB" dirty="0"/>
+              <a:t>Emotional Stability. Say: "Emotional Stability is about composure under pressure and emotional resilience. It shows how a leader behaves when there is stress, criticism, uncertainty or failure. In strategy, emotional stability matters because execution always brings pressure. If leaders become reactive, the team spends its energy managing emotions, and the strategy waits."</a:t>
+            </a:r>
+          </a:p>
+          <a:p>
+            <a:r>
+              <a:rPr lang="en-GB" dirty="0"/>
+              <a:t>Values Alignment. Say: "Values Alignment is about consistency between stated values and lived behaviour. It shows whether a leader’s choices, actions and trade-offs match what the organisation says it stands for. In strategy, values alignment matters because people watch behaviour more closely than slogans. When values and decisions match, trust grows. When they diverge, people comply and commitment weakens."</a:t>
+            </a:r>
+          </a:p>
+          <a:p>
+            <a:r>
+              <a:rPr lang="en-GB" dirty="0"/>
+              <a:t>Learning Orientation. Say: "Learning Orientation is about growth mindset, openness to feedback and skill development. It shows whether a leader can learn, adapt and improve through experience. In strategy, learning orientation matters because strategy is iterative. We decide, test, learn and refine. A team that cannot learn will keep defending old choices even when reality has changed."</a:t>
+            </a:r>
+          </a:p>
+          <a:p/>
+          <a:p>
+            <a:r>
+              <a:rPr lang="en-GB" dirty="0" b="1"/>
+              <a:t>4. Explain the three levels of disposition.</a:t>
+            </a:r>
+          </a:p>
+          <a:p>
+            <a:r>
+              <a:rPr lang="en-GB" dirty="0"/>
+              <a:t>Say: "For each dimension the tool reads the tendency at three levels. Low means the tendency is less visible or less naturally used. Balanced means the tendency is present in a moderate way. High means the tendency is strongly visible."</a:t>
+            </a:r>
+          </a:p>
+          <a:p>
+            <a:r>
+              <a:rPr lang="en-GB" dirty="0"/>
+              <a:t>Say: "Each level carries its own contribution and its own possible risk. A level becomes useful or risky depending on the strategy being carried. The question is: what does this strategy require from us now?"</a:t>
+            </a:r>
+          </a:p>
+          <a:p>
+            <a:r>
+              <a:rPr lang="en-GB" dirty="0"/>
+              <a:t>Say: "For example, high openness may help innovation and may also create too many ideas. Low openness may protect stability and may also delay adaptation. Balanced openness may support careful experimentation and may still avoid uncomfortable change."</a:t>
+            </a:r>
+          </a:p>
+          <a:p>
+            <a:r>
+              <a:rPr lang="en-GB" dirty="0"/>
+              <a:t>Listen for: a High level read as a strength with no risk. Ask participants to read the risk of their High levels first.</a:t>
+            </a:r>
+          </a:p>
+          <a:p/>
+          <a:p>
+            <a:r>
+              <a:rPr lang="en-GB" dirty="0" b="1"/>
+              <a:t>5. Use one worked example: High Agreeableness.</a:t>
+            </a:r>
+          </a:p>
+          <a:p>
+            <a:r>
+              <a:rPr lang="en-GB" dirty="0"/>
+              <a:t>Say: "Let us take one example so that you can see how the tool works. High agreeableness means the leader is kind, warm, cooperative and ready to help. This is a strength because it builds trust. People feel supported and respected."</a:t>
+            </a:r>
+          </a:p>
+          <a:p>
+            <a:r>
+              <a:rPr lang="en-GB" dirty="0"/>
+              <a:t>Say: "The risk is that agreement may be given without real commitment. People may avoid saying no. The team may over-commit because nobody wants to disappoint others. Resentment may build under the surface."</a:t>
+            </a:r>
+          </a:p>
+          <a:p>
+            <a:r>
+              <a:rPr lang="en-GB" dirty="0"/>
+              <a:t>Say: "The response is to create a formal challenge role. Someone must be allowed to ask the difficult question without being seen as negative."</a:t>
+            </a:r>
+          </a:p>
+          <a:p>
+            <a:r>
+              <a:rPr lang="en-GB" dirty="0"/>
+              <a:t>Say: "The routine is the Rotating Challenger. In each major discussion, one person is assigned to challenge assumptions, name risks and ask what the team may be avoiding."</a:t>
+            </a:r>
+          </a:p>
+          <a:p>
+            <a:r>
+              <a:rPr lang="en-GB" dirty="0"/>
+              <a:t>Say: "In Strategy2Results®, this protects alignment. It helps the team move from polite agreement to real commitment."</a:t>
+            </a:r>
+          </a:p>
+          <a:p/>
+          <a:p>
+            <a:r>
+              <a:rPr lang="en-GB" dirty="0" b="1"/>
+              <a:t>6. Say how the assessment works.</a:t>
+            </a:r>
+          </a:p>
+          <a:p>
+            <a:r>
+              <a:rPr lang="en-GB" dirty="0"/>
+              <a:t>Say: "OCEAVL is a personal assessment. Each of you completes it alone. You score yourself from 1 to 5 on each of the seven dimensions: 1 is strongly low, 3 is balanced and 5 is strongly high. A score of 4 or 5 is High, 3 is Balanced, and 1 or 2 is Low. Your profile then shows your level on each dimension, with its risk, its response and three routines."</a:t>
+            </a:r>
+          </a:p>
+          <a:p>
+            <a:r>
+              <a:rPr lang="en-GB" dirty="0"/>
+              <a:t>Say: "This is personal reflection first. Before you compare yourself with anyone, ask: what does this reveal about how I read and lead strategy? No one states a score to the group, and no one records a score for another member."</a:t>
+            </a:r>
+          </a:p>
+          <a:p>
+            <a:r>
+              <a:rPr lang="en-GB" dirty="0"/>
+              <a:t>Say: "Your team sees no names and no single personal scores. The level held by most members is the team’s level for each dimension, and the team sees that level with the count at each level. The team discussion is about what the collective pattern could mean for the strategy."</a:t>
+            </a:r>
+          </a:p>
+          <a:p/>
+          <a:p>
+            <a:r>
+              <a:rPr lang="en-GB" dirty="0" b="1"/>
+              <a:t>7. Close the part.</a:t>
+            </a:r>
+          </a:p>
+          <a:p>
+            <a:r>
+              <a:rPr lang="en-GB" dirty="0"/>
+              <a:t>Say: "OCEAVL helps us see the human pattern behind strategy execution. Once we can see the pattern, we can design the right guardrails. That is how alignment is designed."</a:t>
+            </a:r>
+          </a:p>
+          <a:p/>
+          <a:p>
+            <a:r>
+              <a:rPr lang="en-GB" dirty="0" b="1"/>
+              <a:t>ON THE PORTAL, AFTER THE TEACHING:</a:t>
+            </a:r>
+          </a:p>
+          <a:p>
+            <a:r>
+              <a:rPr lang="en-GB" dirty="0"/>
+              <a:t>Each participant completes the OCEAVL Assessment alone in part 3.1 of the participant file, as portfolio work. They score first and read the seven dimensions afterwards.</a:t>
+            </a:r>
+          </a:p>
+          <a:p>
+            <a:r>
+              <a:rPr lang="en-GB" dirty="0"/>
+              <a:t>1. They score themselves from 1 to 5 on each of the seven dimensions.</a:t>
+            </a:r>
+          </a:p>
+          <a:p>
+            <a:r>
+              <a:rPr lang="en-GB" dirty="0"/>
+              <a:t>2. They read their own profile: for each dimension, the level with its risk, its response and three routines. The full low, balanced and high detail for all seven dimensions is on the page.</a:t>
+            </a:r>
+          </a:p>
+          <a:p>
+            <a:r>
+              <a:rPr lang="en-GB" dirty="0"/>
+              <a:t>3. They select Submit to My Team’s Capstone. Print gives a copy of their own profile.</a:t>
+            </a:r>
+          </a:p>
+          <a:p>
+            <a:r>
+              <a:rPr lang="en-GB" dirty="0"/>
+              <a:t>The team’s profile appears in the team’s Capstone S2R® Blueprint once every member has submitted. Step 2 of Section 5 needs it, so every member submits before the group starts that step.</a:t>
+            </a:r>
+          </a:p>
+          <a:p>
+            <a:r>
+              <a:rPr lang="en-GB" dirty="0"/>
+              <a:t>Each participant then writes the reflection of 3.1: "Which of your own levels carries the highest risk for how you read and lead the strategy? Where has that risk already shown up?"</a:t>
+            </a:r>
           </a:p>
         </p:txBody>
       </p:sp>
@@ -6519,25 +5863,21 @@
           <a:lstStyle/>
           <a:p>
             <a:r>
-              <a:rPr lang="en-GB" b="1" dirty="0"/>
+              <a:rPr lang="en-GB" dirty="0" b="1"/>
               <a:t>SECTION 3 REFLECTIONS</a:t>
             </a:r>
           </a:p>
-          <a:p>
-            <a:endParaRPr lang="en-GB" dirty="0"/>
-          </a:p>
-          <a:p>
-            <a:r>
-              <a:rPr lang="en-GB" b="1" dirty="0"/>
+          <a:p/>
+          <a:p>
+            <a:r>
+              <a:rPr lang="en-GB" dirty="0" b="1"/>
               <a:t>HOW TO USE THIS SLIDE:</a:t>
             </a:r>
           </a:p>
-          <a:p>
-            <a:endParaRPr lang="en-GB" dirty="0"/>
-          </a:p>
-          <a:p>
-            <a:r>
-              <a:rPr lang="en-GB" b="1" dirty="0"/>
+          <a:p/>
+          <a:p>
+            <a:r>
+              <a:rPr lang="en-GB" dirty="0" b="1"/>
               <a:t>1. Show the slide and read the prompt aloud.</a:t>
             </a:r>
           </a:p>
@@ -6547,12 +5887,10 @@
               <a:t>3.1 Reflection — OCEAVL: "Which of your own levels carries the highest risk for how you read and lead the strategy? Where has that risk already shown up?"</a:t>
             </a:r>
           </a:p>
-          <a:p>
-            <a:endParaRPr lang="en-GB" dirty="0"/>
-          </a:p>
-          <a:p>
-            <a:r>
-              <a:rPr lang="en-GB" b="1" dirty="0"/>
+          <a:p/>
+          <a:p>
+            <a:r>
+              <a:rPr lang="en-GB" dirty="0" b="1"/>
               <a:t>2. Say what the reflections are for.</a:t>
             </a:r>
           </a:p>
@@ -6568,21 +5906,17 @@
               <a:t>The reflections build the learning portfolio they receive at the end of the programme.</a:t>
             </a:r>
           </a:p>
-          <a:p>
-            <a:endParaRPr lang="en-GB" dirty="0"/>
-          </a:p>
+          <a:p/>
           <a:p>
             <a:r>
               <a:rPr lang="en-GB" dirty="0"/>
               <a:t>Say: "You write these reflections on the portal after the teaching, with as much depth as you can."</a:t>
             </a:r>
           </a:p>
-          <a:p>
-            <a:endParaRPr lang="en-GB" dirty="0"/>
-          </a:p>
-          <a:p>
-            <a:r>
-              <a:rPr lang="en-GB" b="1" dirty="0"/>
+          <a:p/>
+          <a:p>
+            <a:r>
+              <a:rPr lang="en-GB" dirty="0" b="1"/>
               <a:t>3. Set the standard.</a:t>
             </a:r>
           </a:p>
@@ -6598,27 +5932,23 @@
               <a:t>Watch for: a reflection that lists scores. Ask for one level and its risk.</a:t>
             </a:r>
           </a:p>
-          <a:p>
-            <a:endParaRPr lang="en-GB" dirty="0"/>
-          </a:p>
-          <a:p>
-            <a:r>
-              <a:rPr lang="en-GB" b="1" dirty="0"/>
-              <a:t>4. Bridge to Section 4.</a:t>
-            </a:r>
-          </a:p>
-          <a:p>
-            <a:r>
-              <a:rPr lang="en-GB" dirty="0"/>
-              <a:t>Say: "You know the profile you bring. Section 4 shows how the leadership team holds alignment together."</a:t>
-            </a:r>
-          </a:p>
-          <a:p>
-            <a:endParaRPr lang="en-GB" dirty="0"/>
-          </a:p>
-          <a:p>
-            <a:r>
-              <a:rPr lang="en-GB" b="1" dirty="0"/>
+          <a:p/>
+          <a:p>
+            <a:r>
+              <a:rPr lang="en-GB" dirty="0" b="1"/>
+              <a:t>4. Close Section 3 and bridge to Section 4.</a:t>
+            </a:r>
+          </a:p>
+          <a:p>
+            <a:r>
+              <a:rPr lang="en-GB" dirty="0"/>
+              <a:t>Say: "The team’s behavioural profile shows where alignment is strong and where it carries risk for the strategy. Section 4 examines how the leadership team converges its perspectives into one interpretation and one message."</a:t>
+            </a:r>
+          </a:p>
+          <a:p/>
+          <a:p>
+            <a:r>
+              <a:rPr lang="en-GB" dirty="0" b="1"/>
               <a:t>ON THE PORTAL, AFTER THE TEACHING:</a:t>
             </a:r>
           </a:p>
@@ -6887,143 +6217,78 @@
           <a:lstStyle/>
           <a:p>
             <a:r>
-              <a:rPr lang="en-GB" b="1" dirty="0"/>
+              <a:rPr lang="en-GB" dirty="0" b="1"/>
               <a:t>4.1 — LEADING CHANGE WITH ONE VOICE (FOUR COMMITMENTS)</a:t>
             </a:r>
           </a:p>
-          <a:p>
-            <a:endParaRPr lang="en-GB" dirty="0"/>
-          </a:p>
-          <a:p>
-            <a:r>
-              <a:rPr lang="en-GB" b="1" dirty="0"/>
+          <a:p/>
+          <a:p>
+            <a:r>
+              <a:rPr lang="en-GB" dirty="0" b="1"/>
               <a:t>HOW TO TEACH IT:</a:t>
             </a:r>
           </a:p>
-          <a:p>
-            <a:endParaRPr lang="en-GB" dirty="0"/>
-          </a:p>
-          <a:p>
-            <a:r>
-              <a:rPr lang="en-GB" b="1" dirty="0"/>
-              <a:t>1. Frame the part.</a:t>
-            </a:r>
-          </a:p>
-          <a:p>
-            <a:r>
-              <a:rPr lang="en-GB" dirty="0"/>
-              <a:t>Say: </a:t>
-            </a:r>
-            <a:r>
-              <a:rPr lang="en-ZA" sz="1200" b="0" i="0" kern="1200" dirty="0">
-                <a:solidFill>
-                  <a:schemeClr val="tx1"/>
-                </a:solidFill>
-                <a:effectLst/>
-                <a:latin typeface="+mn-lt"/>
-                <a:ea typeface="+mn-ea"/>
-                <a:cs typeface="+mn-cs"/>
-              </a:rPr>
-              <a:t>The Converging Zone is the point where the separate views of each function come together into one shared reading of the strategy. </a:t>
-            </a:r>
-          </a:p>
-          <a:p>
-            <a:r>
-              <a:rPr lang="en-ZA" sz="1200" b="0" i="0" kern="1200" dirty="0">
-                <a:solidFill>
-                  <a:schemeClr val="tx1"/>
-                </a:solidFill>
-                <a:effectLst/>
-                <a:latin typeface="+mn-lt"/>
-                <a:ea typeface="+mn-ea"/>
-                <a:cs typeface="+mn-cs"/>
-              </a:rPr>
-              <a:t>A leadership team that reaches it has Collective Intelligence, and the organisation hears one voice.</a:t>
-            </a:r>
-            <a:endParaRPr lang="en-GB" dirty="0"/>
-          </a:p>
-          <a:p>
-            <a:endParaRPr lang="en-GB" dirty="0"/>
-          </a:p>
-          <a:p>
-            <a:r>
-              <a:rPr lang="en-GB" dirty="0"/>
-              <a:t>To lead with one voice leaders must send one message, exhibit one example, demonstrate one way of landing the message and assign one leader to keep the glue tight.</a:t>
-            </a:r>
-          </a:p>
-          <a:p>
-            <a:endParaRPr lang="en-GB" dirty="0"/>
-          </a:p>
-          <a:p>
-            <a:r>
-              <a:rPr lang="en-GB" dirty="0"/>
-              <a:t>"The 4 Checks describe what one group of people needs from one leadership team.</a:t>
-            </a:r>
-          </a:p>
-          <a:p>
-            <a:endParaRPr lang="en-GB" dirty="0"/>
-          </a:p>
-          <a:p>
-            <a:r>
-              <a:rPr lang="en-GB" dirty="0"/>
-              <a:t>Most changes reach a group through several leaders at once.</a:t>
-            </a:r>
-          </a:p>
-          <a:p>
-            <a:r>
-              <a:rPr lang="en-GB" dirty="0"/>
-              <a:t>People hear from their own leader, watch the others, and compare.</a:t>
-            </a:r>
-          </a:p>
-          <a:p>
-            <a:endParaRPr lang="en-GB" dirty="0"/>
-          </a:p>
-          <a:p>
-            <a:r>
-              <a:rPr lang="en-GB" dirty="0"/>
-              <a:t>Where the leaders differ, the group takes the difference as the real message."</a:t>
-            </a:r>
-          </a:p>
-          <a:p>
-            <a:endParaRPr lang="en-GB" dirty="0"/>
-          </a:p>
-          <a:p>
-            <a:r>
-              <a:rPr lang="en-GB" dirty="0"/>
-              <a:t>Say: "In the Converging Zone, the leadership team makes four commitments that no single function can make alone. </a:t>
-            </a:r>
-          </a:p>
-          <a:p>
-            <a:endParaRPr lang="en-GB" b="1" dirty="0"/>
-          </a:p>
-          <a:p>
-            <a:r>
-              <a:rPr lang="en-GB" b="1" dirty="0"/>
-              <a:t>2. Teach the four commitments on the slide.</a:t>
-            </a:r>
-          </a:p>
-          <a:p>
-            <a:r>
-              <a:rPr lang="en-GB" b="1" dirty="0"/>
-              <a:t>One message · Protects Mind</a:t>
-            </a:r>
-          </a:p>
-          <a:p>
-            <a:r>
-              <a:rPr lang="en-GB" dirty="0"/>
-              <a:t>Every leader gives the same Shift, Stake and Step for each change. </a:t>
-            </a:r>
-          </a:p>
-          <a:p>
-            <a:r>
-              <a:rPr lang="en-GB" dirty="0"/>
-              <a:t>The test is the 3S Check applied to the leadership team itself. </a:t>
-            </a:r>
-          </a:p>
-          <a:p>
-            <a:r>
-              <a:rPr lang="en-GB" dirty="0"/>
-              <a:t>Each leader writes the three for the same change, and the versions are compared before anyone speaks to their people.</a:t>
+          <a:p/>
+          <a:p>
+            <a:r>
+              <a:rPr lang="en-GB" dirty="0" b="1"/>
+              <a:t>1. Say why one voice matters.</a:t>
+            </a:r>
+          </a:p>
+          <a:p>
+            <a:r>
+              <a:rPr lang="en-GB" dirty="0"/>
+              <a:t>Say: "The 4 Checks describe what one group of people needs from one leader. Most changes reach a group through several leaders at once. People hear from their own leader, watch the others, and compare. Where the leaders differ, the group takes the difference as the real message."</a:t>
+            </a:r>
+          </a:p>
+          <a:p/>
+          <a:p>
+            <a:r>
+              <a:rPr lang="en-GB" dirty="0" b="1"/>
+              <a:t>2. Define the Converging Zone.</a:t>
+            </a:r>
+          </a:p>
+          <a:p>
+            <a:r>
+              <a:rPr lang="en-GB" dirty="0"/>
+              <a:t>Say: "The Converging Zone is the point where the separate views of each function come together into one shared reading of the strategy. A leadership team that reaches it has Collective Intelligence, and the organisation hears one voice."</a:t>
+            </a:r>
+          </a:p>
+          <a:p>
+            <a:r>
+              <a:rPr lang="en-GB" dirty="0"/>
+              <a:t>Say: "With Collective Intelligence, direction remains clear across all layers, resources reinforce priorities, systems enable execution and people move with coordinated effort. One coherent signal reaches the organisation, and changes pass the 4 Checks of Mind, Heart, Hands and Habit."</a:t>
+            </a:r>
+          </a:p>
+          <a:p>
+            <a:r>
+              <a:rPr lang="en-GB" dirty="0"/>
+              <a:t>Say: "Without it, different leaders transmit different interpretations, changes stall at the first check they fail, functions receive competing signals and strategic instability spreads invisibly. Each function becomes a source of execution friction."</a:t>
+            </a:r>
+          </a:p>
+          <a:p>
+            <a:r>
+              <a:rPr lang="en-GB" dirty="0"/>
+              <a:t>Ask: "Which of these two states is your organisation closer to today?"</a:t>
+            </a:r>
+          </a:p>
+          <a:p/>
+          <a:p>
+            <a:r>
+              <a:rPr lang="en-GB" dirty="0" b="1"/>
+              <a:t>3. Teach the four commitments on the slide.</a:t>
+            </a:r>
+          </a:p>
+          <a:p>
+            <a:r>
+              <a:rPr lang="en-GB" dirty="0"/>
+              <a:t>Say: "To lead with one voice, the leadership team makes four commitments that no single function can make alone. Each one protects a check."</a:t>
+            </a:r>
+          </a:p>
+          <a:p>
+            <a:r>
+              <a:rPr lang="en-GB" dirty="0"/>
+              <a:t>One message · Protects Mind. Say: "Every leader gives the same Shift, Stake and Step for each change. The Functional Bias Problem works on leaders first: each one translates the change through their own function before passing it on. The test is the 3S Check applied to the leadership team itself. Each leader writes the three for the same change, and the versions are compared before anyone speaks to their people."</a:t>
             </a:r>
           </a:p>
           <a:p>
@@ -7033,24 +6298,9 @@
             </a:r>
           </a:p>
           <a:p>
-            <a:endParaRPr lang="en-GB" dirty="0"/>
-          </a:p>
-          <a:p>
-            <a:r>
-              <a:rPr lang="en-GB" b="1" dirty="0"/>
-              <a:t>One example · Protects Heart</a:t>
-            </a:r>
-          </a:p>
-          <a:p>
-            <a:r>
-              <a:rPr lang="en-GB" dirty="0"/>
-              <a:t>Leaders show the ACE-IT behaviours the change needs before they ask for them. </a:t>
-            </a:r>
-          </a:p>
-          <a:p>
-            <a:r>
-              <a:rPr lang="en-GB" dirty="0"/>
-              <a:t>People read a leader’s diary, questions and decisions as the real message.</a:t>
+            <a:r>
+              <a:rPr lang="en-GB" dirty="0"/>
+              <a:t>One example · Protects Heart. Say: "Leaders show the ACE-IT behaviours the change needs before they ask for them. People read a leader’s diary, questions and decisions as the real message. A leader who asks for the new practice and keeps to the old one has told the organisation which of the two is safe."</a:t>
             </a:r>
           </a:p>
           <a:p>
@@ -7060,24 +6310,9 @@
             </a:r>
           </a:p>
           <a:p>
-            <a:endParaRPr lang="en-GB" dirty="0"/>
-          </a:p>
-          <a:p>
-            <a:r>
-              <a:rPr lang="en-GB" b="1" dirty="0"/>
-              <a:t>One sequence · Protects Hands</a:t>
-            </a:r>
-          </a:p>
-          <a:p>
-            <a:r>
-              <a:rPr lang="en-GB" dirty="0"/>
-              <a:t>Leaders pool their changes and count how many land on the same group in the same period. </a:t>
-            </a:r>
-          </a:p>
-          <a:p>
-            <a:r>
-              <a:rPr lang="en-GB" dirty="0"/>
-              <a:t>The team then agrees the order and the pace. Time is the first STAT element to give way under the total load.</a:t>
+            <a:r>
+              <a:rPr lang="en-GB" dirty="0"/>
+              <a:t>One sequence · Protects Hands. Say: "Leaders pool their changes and count how many land on the same group in the same period. The team then agrees the order and the pace. Each function sees its own change, and each change looks reasonable alone. The total load on a group is visible only when the team looks together, and Time is the first STAT element to give way under it."</a:t>
             </a:r>
           </a:p>
           <a:p>
@@ -7087,33 +6322,15 @@
             </a:r>
           </a:p>
           <a:p>
-            <a:endParaRPr lang="en-GB" dirty="0"/>
-          </a:p>
-          <a:p>
             <a:r>
               <a:rPr lang="en-GB" dirty="0"/>
               <a:t>Data: employees’ willingness to support enterprise change fell from 74% in 2016 to 43% in 2022, while planned changes per employee rose from two to ten (Gartner, reported in Harvard Business Review, 2023).</a:t>
             </a:r>
           </a:p>
           <a:p>
-            <a:endParaRPr lang="en-GB" dirty="0"/>
-          </a:p>
-          <a:p>
-            <a:r>
-              <a:rPr lang="en-GB" b="1" dirty="0"/>
-              <a:t>One owner · Protects Habit</a:t>
-            </a:r>
-          </a:p>
-          <a:p>
-            <a:r>
-              <a:rPr lang="en-GB" dirty="0"/>
-              <a:t>Each transition has one named leader who answers for adoption, through to Habit. </a:t>
-            </a:r>
-          </a:p>
-          <a:p>
-            <a:r>
-              <a:rPr lang="en-GB" dirty="0"/>
-              <a:t>The owner runs the 4 Checks, reports which check the change has reached, and stays with it after the launch.</a:t>
+            <a:r>
+              <a:rPr lang="en-GB" dirty="0"/>
+              <a:t>One owner · Protects Habit. Say: "Each transition has one named leader who answers for adoption, through to Habit. The owner runs the 4 Checks, reports which check the change has reached, and stays with it after the launch, when attention moves to the next priority."</a:t>
             </a:r>
           </a:p>
           <a:p>
@@ -7123,23 +6340,78 @@
             </a:r>
           </a:p>
           <a:p>
-            <a:endParaRPr lang="en-GB" dirty="0"/>
-          </a:p>
-          <a:p>
             <a:r>
               <a:rPr lang="en-GB" dirty="0"/>
               <a:t>Data: projects with extremely effective sponsors were 79% likely to meet their objectives, against 27% with extremely ineffective sponsors (Prosci, Best Practices in Change Management, 12th edition).</a:t>
             </a:r>
           </a:p>
-          <a:p>
-            <a:endParaRPr lang="en-GB" dirty="0"/>
-          </a:p>
-          <a:p>
-            <a:endParaRPr lang="en-GB" dirty="0"/>
-          </a:p>
-          <a:p>
-            <a:r>
-              <a:rPr lang="en-GB" b="1" dirty="0"/>
+          <a:p/>
+          <a:p>
+            <a:r>
+              <a:rPr lang="en-GB" dirty="0" b="1"/>
+              <a:t>4. Count the change load.</a:t>
+            </a:r>
+          </a:p>
+          <a:p>
+            <a:r>
+              <a:rPr lang="en-GB" dirty="0"/>
+              <a:t>Say: "Choose one named group in your organisation and list in the chat every change the leadership team is asking of it this quarter."</a:t>
+            </a:r>
+          </a:p>
+          <a:p>
+            <a:r>
+              <a:rPr lang="en-GB" dirty="0"/>
+              <a:t>Let the count open the discussion on sequence.</a:t>
+            </a:r>
+          </a:p>
+          <a:p>
+            <a:r>
+              <a:rPr lang="en-GB" dirty="0"/>
+              <a:t>Ask: "If this group can absorb two of these well, which two come first, and who tells the owners of the rest?"</a:t>
+            </a:r>
+          </a:p>
+          <a:p>
+            <a:r>
+              <a:rPr lang="en-GB" dirty="0"/>
+              <a:t>Listen for: each leader defending their own change. Return the discussion to the group that has to absorb them.</a:t>
+            </a:r>
+          </a:p>
+          <a:p/>
+          <a:p>
+            <a:r>
+              <a:rPr lang="en-GB" dirty="0" b="1"/>
+              <a:t>5. Test one message on the room.</a:t>
+            </a:r>
+          </a:p>
+          <a:p>
+            <a:r>
+              <a:rPr lang="en-GB" dirty="0"/>
+              <a:t>Repeat the 3S test from 1.3.1 with the whole team on one enterprise-wide change. Participants post their Shift, Stake and Step in the chat, and the room compares the versions.</a:t>
+            </a:r>
+          </a:p>
+          <a:p>
+            <a:r>
+              <a:rPr lang="en-GB" dirty="0"/>
+              <a:t>Ask: "What is the single most important convergence you need to achieve before your next major strategy initiative?"</a:t>
+            </a:r>
+          </a:p>
+          <a:p/>
+          <a:p>
+            <a:r>
+              <a:rPr lang="en-GB" dirty="0" b="1"/>
+              <a:t>6. Bridge to 4.2.</a:t>
+            </a:r>
+          </a:p>
+          <a:p>
+            <a:r>
+              <a:rPr lang="en-GB" dirty="0"/>
+              <a:t>Say: "One voice depends on every role. 4.2 shows what each role brings to the shared reading of the strategy, and where each role is most likely to lose people."</a:t>
+            </a:r>
+          </a:p>
+          <a:p/>
+          <a:p>
+            <a:r>
+              <a:rPr lang="en-GB" dirty="0" b="1"/>
               <a:t>ON THE PORTAL, AFTER THE TEACHING:</a:t>
             </a:r>
           </a:p>
@@ -7238,16 +6510,14 @@
           <a:lstStyle/>
           <a:p>
             <a:r>
-              <a:rPr lang="en-GB" b="1" dirty="0"/>
+              <a:rPr lang="en-GB" dirty="0" b="1"/>
               <a:t>FACILITATOR GUIDE · SESSION OVERVIEW</a:t>
             </a:r>
           </a:p>
-          <a:p>
-            <a:endParaRPr lang="en-GB" dirty="0"/>
-          </a:p>
-          <a:p>
-            <a:r>
-              <a:rPr lang="en-GB" b="1" dirty="0"/>
+          <a:p/>
+          <a:p>
+            <a:r>
+              <a:rPr lang="en-GB" dirty="0" b="1"/>
               <a:t>HOW TO USE THIS SLIDE:</a:t>
             </a:r>
           </a:p>
@@ -7270,11 +6540,15 @@
             </a:r>
           </a:p>
           <a:p>
-            <a:endParaRPr lang="en-GB" dirty="0"/>
-          </a:p>
-          <a:p>
-            <a:r>
-              <a:rPr lang="en-GB" b="1" dirty="0"/>
+            <a:r>
+              <a:rPr lang="en-GB" dirty="0"/>
+              <a:t>4. Bridge to Section 1. Say: "We start where every strategy starts its journey into execution: with the people who have to carry it."</a:t>
+            </a:r>
+          </a:p>
+          <a:p/>
+          <a:p>
+            <a:r>
+              <a:rPr lang="en-GB" dirty="0" b="1"/>
               <a:t>THE FIVE SECTIONS:</a:t>
             </a:r>
           </a:p>
@@ -7284,114 +6558,35 @@
               <a:t>- Section 1 · Awareness — What: the two human filters, the five principles, then change management: the 4 Checks of Mind, Heart, Hands and Habit and the tool for each check (3S, SCARF, STAT, ACE-IT).</a:t>
             </a:r>
           </a:p>
-          <a:p>
-            <a:endParaRPr lang="en-GB" dirty="0"/>
-          </a:p>
+          <a:p/>
           <a:p>
             <a:r>
               <a:rPr lang="en-GB" dirty="0"/>
               <a:t>- Section 2 · Intelligence — Why: the ignition point of execution, the three foundational logics, and why a change delivers value only when it is adopted.</a:t>
             </a:r>
           </a:p>
-          <a:p>
-            <a:endParaRPr lang="en-GB" dirty="0"/>
-          </a:p>
+          <a:p/>
           <a:p>
             <a:r>
               <a:rPr lang="en-GB" dirty="0"/>
               <a:t>- Section 3 · Extrapolating — Where: the OCEAVL Assessment, which each participant completes for themselves, and the profile the team brings together.</a:t>
             </a:r>
           </a:p>
-          <a:p>
-            <a:endParaRPr lang="en-GB" dirty="0"/>
-          </a:p>
+          <a:p/>
           <a:p>
             <a:r>
               <a:rPr lang="en-GB" dirty="0"/>
               <a:t>- Section 4 · Integration — Collective: leading change with one voice, then the Converging Zone Contribution and the Alignment Hot Zone of each leadership role.</a:t>
             </a:r>
           </a:p>
-          <a:p>
-            <a:endParaRPr lang="en-GB" dirty="0"/>
-          </a:p>
+          <a:p/>
           <a:p>
             <a:r>
               <a:rPr lang="en-GB" dirty="0"/>
               <a:t>- Section 5 · Application — In Practice: Leading with Clarity. Each group states its Shift, Stake and Step, then the ACE-IT behaviours it expects from the leadership team.</a:t>
             </a:r>
           </a:p>
-          <a:p>
-            <a:endParaRPr lang="en-GB" dirty="0"/>
-          </a:p>
-          <a:p>
-            <a:r>
-              <a:rPr lang="en-GB" b="1" dirty="0"/>
-              <a:t>KEY FACILITATION QUESTIONS:</a:t>
-            </a:r>
-          </a:p>
-          <a:p>
-            <a:r>
-              <a:rPr lang="en-GB" dirty="0"/>
-              <a:t>- "What is the dominant emotion your team carries into the current strategy, and how does it change what people invest?"</a:t>
-            </a:r>
-          </a:p>
-          <a:p>
-            <a:r>
-              <a:rPr lang="en-GB" dirty="0"/>
-              <a:t>- "Which SCARF trigger does the current strategy activate most for your people?"</a:t>
-            </a:r>
-          </a:p>
-          <a:p>
-            <a:r>
-              <a:rPr lang="en-GB" dirty="0"/>
-              <a:t>- "For the most important change in your strategy, which check would your people fail first: Mind, Heart, Hands or Habit?"</a:t>
-            </a:r>
-          </a:p>
-          <a:p>
-            <a:r>
-              <a:rPr lang="en-GB" dirty="0"/>
-              <a:t>- "On which OCEAVL dimension does your team’s level carry the highest risk for this strategy? Where has that risk already shown up?"</a:t>
-            </a:r>
-          </a:p>
-          <a:p>
-            <a:r>
-              <a:rPr lang="en-GB" dirty="0"/>
-              <a:t>- "What behavioural change will you model in the next month so others can see alignment in action?"</a:t>
-            </a:r>
-          </a:p>
-          <a:p>
-            <a:endParaRPr lang="en-GB" dirty="0"/>
-          </a:p>
-          <a:p>
-            <a:r>
-              <a:rPr lang="en-GB" b="1" dirty="0"/>
-              <a:t>TONE AND WATCH POINTS:</a:t>
-            </a:r>
-          </a:p>
-          <a:p>
-            <a:r>
-              <a:rPr lang="en-GB" dirty="0"/>
-              <a:t>- Watch for compliance mistaken for commitment. Probe: "Would they still act this way if no one were checking?"</a:t>
-            </a:r>
-          </a:p>
-          <a:p>
-            <a:r>
-              <a:rPr lang="en-GB" dirty="0"/>
-              <a:t>- Watch for installation reported as adoption. Probe: "Would the new practice hold on a busy day with no one checking?"</a:t>
-            </a:r>
-          </a:p>
-          <a:p>
-            <a:r>
-              <a:rPr lang="en-GB" dirty="0"/>
-              <a:t>- Watch for emotion treated as a side topic. Connect each emotional state to an execution consequence.</a:t>
-            </a:r>
-          </a:p>
-          <a:p>
-            <a:r>
-              <a:rPr lang="en-GB" dirty="0"/>
-              <a:t>- Watch for expected behaviours that describe intentions. Each behaviour must be observable by the team.</a:t>
-            </a:r>
-          </a:p>
+          <a:p/>
         </p:txBody>
       </p:sp>
       <p:sp>
@@ -7475,75 +6670,75 @@
           <a:lstStyle/>
           <a:p>
             <a:r>
-              <a:rPr lang="en-GB" b="1" dirty="0"/>
+              <a:rPr lang="en-GB" dirty="0" b="1"/>
               <a:t>4.2 — COLLECTIVE INTELLIGENCE ACROSS THE LEADERSHIP TEAM (CLICK A ROLE)</a:t>
             </a:r>
           </a:p>
-          <a:p>
-            <a:endParaRPr lang="en-GB" dirty="0"/>
-          </a:p>
-          <a:p>
-            <a:r>
-              <a:rPr lang="en-GB" b="1" dirty="0"/>
+          <a:p/>
+          <a:p>
+            <a:r>
+              <a:rPr lang="en-GB" dirty="0" b="1"/>
               <a:t>HOW TO TEACH IT:</a:t>
             </a:r>
           </a:p>
-          <a:p>
-            <a:endParaRPr lang="en-GB" dirty="0"/>
-          </a:p>
-          <a:p>
-            <a:r>
-              <a:rPr lang="en-GB" b="1" dirty="0"/>
+          <a:p/>
+          <a:p>
+            <a:r>
+              <a:rPr lang="en-GB" dirty="0" b="1"/>
               <a:t>1. Frame the grid on the slide.</a:t>
             </a:r>
           </a:p>
           <a:p>
             <a:r>
-              <a:rPr lang="en-ZA" dirty="0"/>
-              <a:t>They are the </a:t>
-            </a:r>
-            <a:r>
-              <a:rPr lang="en-ZA" b="1" dirty="0"/>
-              <a:t>specific alignment responsibilities each executive role must clarify when the organisation is moving through change or a new strategic trajectory</a:t>
-            </a:r>
-            <a:r>
-              <a:rPr lang="en-ZA" dirty="0"/>
-              <a:t>.</a:t>
-            </a:r>
-          </a:p>
-          <a:p>
-            <a:r>
-              <a:rPr lang="en-ZA" dirty="0"/>
-              <a:t>“Every role carries a different part of the change into the organisation. If that role does not clarify its part, people lose alignment at that point.”</a:t>
-            </a:r>
-          </a:p>
-          <a:p>
-            <a:endParaRPr lang="en-ZA" dirty="0"/>
-          </a:p>
-          <a:p>
-            <a:r>
-              <a:rPr lang="en-ZA" dirty="0"/>
-              <a:t>That means for example - The CEO can clarify direction, but the CFO must clarify resource logic, the COO must clarify operating capacity, and the CHRO must clarify human capability.</a:t>
-            </a:r>
-          </a:p>
-          <a:p>
-            <a:endParaRPr lang="en-ZA" dirty="0"/>
-          </a:p>
-          <a:p>
-            <a:r>
-              <a:rPr lang="en-ZA" dirty="0"/>
-              <a:t>What is important is for leaders to know which lever to pull when aligning people heart and mind to create collective intelligence for execution whether as a leadership team or as a leader for a team.</a:t>
-            </a:r>
-          </a:p>
-          <a:p>
-            <a:endParaRPr lang="en-GB" dirty="0"/>
-          </a:p>
-          <a:p>
-            <a:r>
-              <a:rPr lang="en-GB" b="1" dirty="0"/>
-              <a:t>3. Walk some selected roles</a:t>
-            </a:r>
-          </a:p>
+              <a:rPr lang="en-GB" dirty="0"/>
+              <a:t>Say: "Every role on a leadership team affects alignment in two ways at once. Each role carries a different part of the change into the organisation. If that role does not clarify its part, people lose alignment at that point."</a:t>
+            </a:r>
+          </a:p>
+          <a:p>
+            <a:r>
+              <a:rPr lang="en-GB" dirty="0"/>
+              <a:t>Say: "The CEO clarifies direction. The CFO must clarify resource logic, the COO operating capacity and the CHRO human capability. Leaders need to know which lever to pull when aligning people’s hearts and minds, whether as a leadership team or as the leader of a team."</a:t>
+            </a:r>
+          </a:p>
+          <a:p/>
+          <a:p>
+            <a:r>
+              <a:rPr lang="en-GB" dirty="0" b="1"/>
+              <a:t>2. Teach the two terms.</a:t>
+            </a:r>
+          </a:p>
+          <a:p>
+            <a:r>
+              <a:rPr lang="en-GB" dirty="0"/>
+              <a:t>Say: "The Converging Zone Contribution is what a role brings so that the leadership team reads the strategy as one. It is the part of that shared reading only that role can supply."</a:t>
+            </a:r>
+          </a:p>
+          <a:p>
+            <a:r>
+              <a:rPr lang="en-GB" dirty="0"/>
+              <a:t>Say: "The Alignment Hot Zone is the one place where a role is most likely to lose people as it does its normal work. It is one of the 17 elements of 3S, SCARF, STAT and ACE-IT taught in 1.3.1 to 1.3.4. It tells the leader which check the role puts at risk: people’s understanding (Mind), their willingness (Heart), their ability to act (Hands) or their follow-through (Habit)."</a:t>
+            </a:r>
+          </a:p>
+          <a:p>
+            <a:r>
+              <a:rPr lang="en-GB" dirty="0"/>
+              <a:t>Say: "The two come from the same work. The work that makes a role valuable to the team is the work that creates its hot zone. The CEO sets direction: that is the contribution. A direction announced in broad terms leaves people unsure what changes for them: that is the hot zone. A leader who knows both keeps giving the contribution and guards the hot zone."</a:t>
+            </a:r>
+          </a:p>
+          <a:p/>
+          <a:p>
+            <a:r>
+              <a:rPr lang="en-GB" dirty="0" b="1"/>
+              <a:t>3. Walk the roles, starting with the CEO.</a:t>
+            </a:r>
+          </a:p>
+          <a:p>
+            <a:r>
+              <a:rPr lang="en-GB" dirty="0"/>
+              <a:t>Use the CEO card as the example: the contribution first, then the hot zone, and the one piece of work that produces both. Then take the roles in the room.</a:t>
+            </a:r>
+          </a:p>
+          <a:p/>
           <a:p>
             <a:r>
               <a:rPr lang="en-GB" dirty="0"/>
@@ -7598,9 +6793,7 @@
               <a:t>When the CEO’s alignment is absent or inconsistent, all other roles struggle to converge.</a:t>
             </a:r>
           </a:p>
-          <a:p>
-            <a:endParaRPr lang="en-GB" dirty="0"/>
-          </a:p>
+          <a:p/>
           <a:p>
             <a:r>
               <a:rPr lang="en-GB" dirty="0"/>
@@ -7649,9 +6842,7 @@
               <a:t>When the CFO’s alignment is absent, resources follow inertia, and the credibility of strategic priorities collapses.</a:t>
             </a:r>
           </a:p>
-          <a:p>
-            <a:endParaRPr lang="en-GB" dirty="0"/>
-          </a:p>
+          <a:p/>
           <a:p>
             <a:r>
               <a:rPr lang="en-GB" dirty="0"/>
@@ -7700,9 +6891,7 @@
               <a:t>When COO alignment is absent, execution machinery runs efficiently but in the wrong direction.</a:t>
             </a:r>
           </a:p>
-          <a:p>
-            <a:endParaRPr lang="en-GB" dirty="0"/>
-          </a:p>
+          <a:p/>
           <a:p>
             <a:r>
               <a:rPr lang="en-GB" dirty="0"/>
@@ -7751,9 +6940,7 @@
               <a:t>When CHRO alignment is absent, strategy consistently exceeds the human system’s capacity to carry it.</a:t>
             </a:r>
           </a:p>
-          <a:p>
-            <a:endParaRPr lang="en-GB" dirty="0"/>
-          </a:p>
+          <a:p/>
           <a:p>
             <a:r>
               <a:rPr lang="en-GB" dirty="0"/>
@@ -7802,9 +6989,7 @@
               <a:t>When CTO/CIO alignment is absent, technology investments produce demonstrations with no capability shift.</a:t>
             </a:r>
           </a:p>
-          <a:p>
-            <a:endParaRPr lang="en-GB" dirty="0"/>
-          </a:p>
+          <a:p/>
           <a:p>
             <a:r>
               <a:rPr lang="en-GB" dirty="0"/>
@@ -7853,9 +7038,7 @@
               <a:t>When CMO alignment is absent, market signals are disconnected from strategic direction, and brand promises outpace operational reality.</a:t>
             </a:r>
           </a:p>
-          <a:p>
-            <a:endParaRPr lang="en-GB" dirty="0"/>
-          </a:p>
+          <a:p/>
           <a:p>
             <a:r>
               <a:rPr lang="en-GB" dirty="0"/>
@@ -7904,9 +7087,7 @@
               <a:t>When CCO alignment is absent, growth strategies create internal incoherence that compounds over time.</a:t>
             </a:r>
           </a:p>
-          <a:p>
-            <a:endParaRPr lang="en-GB" dirty="0"/>
-          </a:p>
+          <a:p/>
           <a:p>
             <a:r>
               <a:rPr lang="en-GB" dirty="0"/>
@@ -7955,9 +7136,7 @@
               <a:t>When CPO alignment is absent, procurement optimises for cost at the expense of strategic capability.</a:t>
             </a:r>
           </a:p>
-          <a:p>
-            <a:endParaRPr lang="en-GB" dirty="0"/>
-          </a:p>
+          <a:p/>
           <a:p>
             <a:r>
               <a:rPr lang="en-GB" dirty="0"/>
@@ -8054,15 +7233,67 @@
               <a:t>When CSO alignment is absent, the strategic narrative fragments and different layers execute different versions of the strategy.</a:t>
             </a:r>
           </a:p>
-          <a:p>
-            <a:endParaRPr lang="en-GB" dirty="0"/>
-          </a:p>
-          <a:p>
-            <a:endParaRPr lang="en-GB" b="1" dirty="0"/>
-          </a:p>
-          <a:p>
-            <a:r>
-              <a:rPr lang="en-GB" b="1" dirty="0"/>
+          <a:p/>
+          <a:p>
+            <a:r>
+              <a:rPr lang="en-GB" dirty="0" b="1"/>
+              <a:t>4. Ask each leader to read their own role.</a:t>
+            </a:r>
+          </a:p>
+          <a:p>
+            <a:r>
+              <a:rPr lang="en-GB" dirty="0"/>
+              <a:t>Ask each participant to find their own role first.</a:t>
+            </a:r>
+          </a:p>
+          <a:p>
+            <a:r>
+              <a:rPr lang="en-GB" dirty="0"/>
+              <a:t>Ask: "Do you recognise this description? Is this how your team experiences your alignment contribution?"</a:t>
+            </a:r>
+          </a:p>
+          <a:p>
+            <a:r>
+              <a:rPr lang="en-GB" dirty="0"/>
+              <a:t>Then ask them to read the roles closest to their own. This is particularly powerful when the full CXO team attends.</a:t>
+            </a:r>
+          </a:p>
+          <a:p/>
+          <a:p>
+            <a:r>
+              <a:rPr lang="en-GB" dirty="0" b="1"/>
+              <a:t>5. Name the next alignment conversation.</a:t>
+            </a:r>
+          </a:p>
+          <a:p>
+            <a:r>
+              <a:rPr lang="en-GB" dirty="0"/>
+              <a:t>Ask: "Look at the role most adjacent to yours. What is the most important alignment conversation you need to have next with that role?"</a:t>
+            </a:r>
+          </a:p>
+          <a:p>
+            <a:r>
+              <a:rPr lang="en-GB" dirty="0"/>
+              <a:t>The answer frequently becomes a direct commitment after the session.</a:t>
+            </a:r>
+          </a:p>
+          <a:p/>
+          <a:p>
+            <a:r>
+              <a:rPr lang="en-GB" dirty="0" b="1"/>
+              <a:t>6. Bridge to the reflections.</a:t>
+            </a:r>
+          </a:p>
+          <a:p>
+            <a:r>
+              <a:rPr lang="en-GB" dirty="0"/>
+              <a:t>Say: "When any role drops its contribution, the rest cannot fully converge. Collective Intelligence is the combined signal. Two reflections close this section."</a:t>
+            </a:r>
+          </a:p>
+          <a:p/>
+          <a:p>
+            <a:r>
+              <a:rPr lang="en-GB" dirty="0" b="1"/>
               <a:t>ON THE PORTAL, AFTER THE TEACHING:</a:t>
             </a:r>
           </a:p>
@@ -8161,25 +7392,21 @@
           <a:lstStyle/>
           <a:p>
             <a:r>
-              <a:rPr lang="en-GB" b="1" dirty="0"/>
+              <a:rPr lang="en-GB" dirty="0" b="1"/>
               <a:t>SECTION 4 REFLECTIONS</a:t>
             </a:r>
           </a:p>
-          <a:p>
-            <a:endParaRPr lang="en-GB" dirty="0"/>
-          </a:p>
-          <a:p>
-            <a:r>
-              <a:rPr lang="en-GB" b="1" dirty="0"/>
+          <a:p/>
+          <a:p>
+            <a:r>
+              <a:rPr lang="en-GB" dirty="0" b="1"/>
               <a:t>HOW TO USE THIS SLIDE:</a:t>
             </a:r>
           </a:p>
-          <a:p>
-            <a:endParaRPr lang="en-GB" dirty="0"/>
-          </a:p>
-          <a:p>
-            <a:r>
-              <a:rPr lang="en-GB" b="1" dirty="0"/>
+          <a:p/>
+          <a:p>
+            <a:r>
+              <a:rPr lang="en-GB" dirty="0" b="1"/>
               <a:t>1. Show the slide and read the prompts aloud.</a:t>
             </a:r>
           </a:p>
@@ -8189,21 +7416,17 @@
               <a:t>4.1 Reflection — One voice: "Choose one group in your organisation. List every change the leadership team is asking of it this quarter. How many are there? Which of the four commitments is weakest in your team today?"</a:t>
             </a:r>
           </a:p>
-          <a:p>
-            <a:endParaRPr lang="en-GB" dirty="0"/>
-          </a:p>
+          <a:p/>
           <a:p>
             <a:r>
               <a:rPr lang="en-GB" dirty="0"/>
               <a:t>4.2 Reflection: "What is the most important alignment conversation you need to have next with a closely adjacent role? What would that conversation need to address?"</a:t>
             </a:r>
           </a:p>
-          <a:p>
-            <a:endParaRPr lang="en-GB" dirty="0"/>
-          </a:p>
-          <a:p>
-            <a:r>
-              <a:rPr lang="en-GB" b="1" dirty="0"/>
+          <a:p/>
+          <a:p>
+            <a:r>
+              <a:rPr lang="en-GB" dirty="0" b="1"/>
               <a:t>2. Say what the reflections are for.</a:t>
             </a:r>
           </a:p>
@@ -8219,21 +7442,17 @@
               <a:t>The reflections build the learning portfolio they receive at the end of the programme.</a:t>
             </a:r>
           </a:p>
-          <a:p>
-            <a:endParaRPr lang="en-GB" dirty="0"/>
-          </a:p>
+          <a:p/>
           <a:p>
             <a:r>
               <a:rPr lang="en-GB" dirty="0"/>
               <a:t>Say: "You write these reflections on the portal after the teaching, with as much depth as you can."</a:t>
             </a:r>
           </a:p>
-          <a:p>
-            <a:endParaRPr lang="en-GB" dirty="0"/>
-          </a:p>
-          <a:p>
-            <a:r>
-              <a:rPr lang="en-GB" b="1" dirty="0"/>
+          <a:p/>
+          <a:p>
+            <a:r>
+              <a:rPr lang="en-GB" dirty="0" b="1"/>
               <a:t>3. Set the standard.</a:t>
             </a:r>
           </a:p>
@@ -8249,27 +7468,23 @@
               <a:t>Watch for: a conversation with no named role. Ask: "Which role, and by when?"</a:t>
             </a:r>
           </a:p>
-          <a:p>
-            <a:endParaRPr lang="en-GB" dirty="0"/>
-          </a:p>
-          <a:p>
-            <a:r>
-              <a:rPr lang="en-GB" b="1" dirty="0"/>
-              <a:t>4. Bridge to Section 5.</a:t>
-            </a:r>
-          </a:p>
-          <a:p>
-            <a:r>
-              <a:rPr lang="en-GB" dirty="0"/>
-              <a:t>Say: "We have the checks, the commitments and the hot zones. Section 5 applies two of the tools to the strategy in your Capstone Blueprint."</a:t>
-            </a:r>
-          </a:p>
-          <a:p>
-            <a:endParaRPr lang="en-GB" dirty="0"/>
-          </a:p>
-          <a:p>
-            <a:r>
-              <a:rPr lang="en-GB" b="1" dirty="0"/>
+          <a:p/>
+          <a:p>
+            <a:r>
+              <a:rPr lang="en-GB" dirty="0" b="1"/>
+              <a:t>4. Close Section 4 and bridge to Section 5.</a:t>
+            </a:r>
+          </a:p>
+          <a:p>
+            <a:r>
+              <a:rPr lang="en-GB" dirty="0"/>
+              <a:t>Say: "A leadership team aligns people when its members interpret the strategy together and speak about the change with one voice. In Section 5 each group states the change its strategy requires and the leadership behaviours that will hold it in place."</a:t>
+            </a:r>
+          </a:p>
+          <a:p/>
+          <a:p>
+            <a:r>
+              <a:rPr lang="en-GB" dirty="0" b="1"/>
               <a:t>ON THE PORTAL, AFTER THE TEACHING:</a:t>
             </a:r>
           </a:p>
@@ -8346,149 +7561,141 @@
           <a:lstStyle/>
           <a:p>
             <a:r>
-              <a:rPr lang="en-GB"/>
+              <a:rPr lang="en-GB" dirty="0"/>
               <a:t>SECTION 5 · APPLICATION — IN PRACTICE</a:t>
             </a:r>
           </a:p>
-          <a:p>
-            <a:endParaRPr lang="en-GB"/>
-          </a:p>
-          <a:p>
-            <a:r>
-              <a:rPr lang="en-GB"/>
+          <a:p/>
+          <a:p>
+            <a:r>
+              <a:rPr lang="en-GB" dirty="0"/>
               <a:t>HOW THIS SECTION RUNS:</a:t>
             </a:r>
           </a:p>
           <a:p>
             <a:r>
-              <a:rPr lang="en-GB"/>
-              <a:t>Step 1 · The 3S Check. Your group states three things for the strategy in your Capstone Blueprint: the Shift (what is changing), the Stake (what the organisation gains if it changes, and what it loses if it stays as it is) and the Step (what must be done differently). The guide from part 1.3.1 sits beside each box.</a:t>
-            </a:r>
-          </a:p>
-          <a:p>
-            <a:endParaRPr lang="en-GB"/>
-          </a:p>
-          <a:p>
-            <a:r>
-              <a:rPr lang="en-GB"/>
+              <a:rPr lang="en-GB" dirty="0"/>
+              <a:t>Step 1 · The 3S Check. Your group states three things for the strategy in your Capstone S2R® Blueprint: the Shift (what is changing), the Stake (what the organisation gains if it changes, and what it loses if it stays as it is) and the Step (what must be done differently). The guide from part 1.3.1 sits beside each box.</a:t>
+            </a:r>
+          </a:p>
+          <a:p/>
+          <a:p>
+            <a:r>
+              <a:rPr lang="en-GB" dirty="0"/>
               <a:t>Step 2 · ACE-IT. Your group reads its team OCEAVL profile and names the two dimensions on which the team carries the highest risk for the strategy, with the response to each. It then states the behaviour it expects from the leadership team under each of the five ACE-IT behaviours: Accountability, Commitment, Engagement, Integrity and Transparency. The guide from part 1.3.4 sits beside each box.</a:t>
             </a:r>
           </a:p>
           <a:p>
             <a:r>
-              <a:rPr lang="en-GB"/>
-              <a:t>You then select Agree. This is Capstone work, and when every member has agreed, your record feeds your team’s Capstone Blueprint.</a:t>
-            </a:r>
-          </a:p>
-          <a:p>
-            <a:endParaRPr lang="en-GB"/>
-          </a:p>
-          <a:p>
-            <a:r>
-              <a:rPr lang="en-GB"/>
+              <a:rPr lang="en-GB" dirty="0"/>
+              <a:t>You then select Agree. This is Capstone work, and when every member has agreed, your record feeds your team’s Capstone S2R® Blueprint.</a:t>
+            </a:r>
+          </a:p>
+          <a:p/>
+          <a:p>
+            <a:r>
+              <a:rPr lang="en-GB" dirty="0"/>
               <a:t>SECTION LEARNING OUTCOMES:</a:t>
             </a:r>
           </a:p>
           <a:p>
             <a:r>
-              <a:rPr lang="en-GB"/>
+              <a:rPr lang="en-GB" dirty="0"/>
               <a:t>1. Develop an approach to landing the strategy that builds understanding, readiness and adoption.</a:t>
             </a:r>
           </a:p>
           <a:p>
             <a:r>
-              <a:rPr lang="en-GB"/>
+              <a:rPr lang="en-GB" dirty="0"/>
               <a:t>2. Model and reinforce leadership behaviours that strengthen collective strategic alignment.</a:t>
             </a:r>
           </a:p>
-          <a:p>
-            <a:endParaRPr lang="en-GB"/>
-          </a:p>
-          <a:p>
-            <a:r>
-              <a:rPr lang="en-GB"/>
+          <a:p/>
+          <a:p>
+            <a:r>
+              <a:rPr lang="en-GB" dirty="0"/>
               <a:t>HOW TO OPEN THE SECTION:</a:t>
             </a:r>
           </a:p>
-          <a:p>
-            <a:endParaRPr lang="en-GB"/>
-          </a:p>
-          <a:p>
-            <a:r>
-              <a:rPr lang="en-GB"/>
+          <a:p/>
+          <a:p>
+            <a:r>
+              <a:rPr lang="en-GB" dirty="0"/>
               <a:t>1. Say what the section does.</a:t>
             </a:r>
           </a:p>
           <a:p>
             <a:r>
-              <a:rPr lang="en-GB"/>
+              <a:rPr lang="en-GB" dirty="0"/>
               <a:t>Say: "In this section your group builds the case for the change your strategy asks of people.</a:t>
             </a:r>
           </a:p>
           <a:p>
             <a:r>
-              <a:rPr lang="en-GB"/>
+              <a:rPr lang="en-GB" dirty="0"/>
               <a:t>With the 3S Check you state the change.</a:t>
             </a:r>
           </a:p>
           <a:p>
             <a:r>
-              <a:rPr lang="en-GB"/>
+              <a:rPr lang="en-GB" dirty="0"/>
               <a:t>With ACE-IT you state the leadership behaviours that will hold it in place."</a:t>
             </a:r>
           </a:p>
-          <a:p>
-            <a:endParaRPr lang="en-GB"/>
-          </a:p>
-          <a:p>
-            <a:r>
-              <a:rPr lang="en-GB"/>
+          <a:p/>
+          <a:p>
+            <a:r>
+              <a:rPr lang="en-GB" dirty="0"/>
               <a:t>2. Say how the group works.</a:t>
             </a:r>
           </a:p>
           <a:p>
             <a:r>
-              <a:rPr lang="en-GB"/>
+              <a:rPr lang="en-GB" dirty="0"/>
               <a:t>Say: "Both steps are group work.</a:t>
             </a:r>
           </a:p>
           <a:p>
             <a:r>
-              <a:rPr lang="en-GB"/>
+              <a:rPr lang="en-GB" dirty="0"/>
               <a:t>Your group agrees each entry.</a:t>
             </a:r>
           </a:p>
           <a:p>
             <a:r>
-              <a:rPr lang="en-GB"/>
+              <a:rPr lang="en-GB" dirty="0"/>
               <a:t>Your group chooses its scribe for this work.</a:t>
             </a:r>
           </a:p>
           <a:p>
             <a:r>
-              <a:rPr lang="en-GB"/>
+              <a:rPr lang="en-GB" dirty="0"/>
               <a:t>The entries appear on every member’s page, and each member then selects Agree."</a:t>
             </a:r>
           </a:p>
-          <a:p>
-            <a:endParaRPr lang="en-GB"/>
-          </a:p>
-          <a:p>
-            <a:r>
-              <a:rPr lang="en-GB"/>
+          <a:p/>
+          <a:p>
+            <a:r>
+              <a:rPr lang="en-GB" dirty="0"/>
               <a:t>3. Say where the work goes.</a:t>
             </a:r>
           </a:p>
           <a:p>
             <a:r>
-              <a:rPr lang="en-GB"/>
-              <a:t>Say: "This is Capstone work. Your group’s confirmed record feeds your team’s Capstone Blueprint."</a:t>
-            </a:r>
-          </a:p>
-          <a:p>
-            <a:r>
-              <a:rPr lang="en-GB"/>
+              <a:rPr lang="en-GB" dirty="0"/>
+              <a:t>Say: "This is Capstone work. Your group’s confirmed record feeds your team’s Capstone S2R® Blueprint."</a:t>
+            </a:r>
+          </a:p>
+          <a:p>
+            <a:r>
+              <a:rPr lang="en-GB" dirty="0"/>
               <a:t>Step 2 needs the team’s OCEAVL profile. Every member completes and submits the assessment in 3.1 first.</a:t>
+            </a:r>
+          </a:p>
+          <a:p>
+            <a:r>
+              <a:rPr lang="en-GB" dirty="0"/>
+              <a:t>Close the group work with Our Position. Say: "When your record is complete, write as a group a short summary statement of your team's position from this unit, in the unit's own terms. Every member agrees it with the rest of the record. It closes this unit's section of your Capstone S2R Blueprint and guides the assessors through your work."</a:t>
             </a:r>
           </a:p>
         </p:txBody>
@@ -8634,51 +7841,20 @@
           <a:lstStyle/>
           <a:p>
             <a:r>
-              <a:rPr lang="en-GB" b="1" dirty="0"/>
+              <a:rPr lang="en-GB" dirty="0" b="1"/>
               <a:t>SECTION 5 · STEP 1 — THE 3S CHECK (CAPSTONE WORK)</a:t>
             </a:r>
           </a:p>
-          <a:p>
-            <a:endParaRPr lang="en-GB" dirty="0"/>
-          </a:p>
-          <a:p>
-            <a:r>
-              <a:rPr lang="en-GB" b="1" dirty="0"/>
+          <a:p/>
+          <a:p>
+            <a:r>
+              <a:rPr lang="en-GB" dirty="0" b="1"/>
               <a:t>HOW TO TEACH IT:</a:t>
             </a:r>
           </a:p>
           <a:p>
             <a:r>
-              <a:rPr lang="en-ZA" sz="1200" b="0" i="0" kern="1200" dirty="0">
-                <a:solidFill>
-                  <a:schemeClr val="tx1"/>
-                </a:solidFill>
-                <a:effectLst/>
-                <a:latin typeface="+mn-lt"/>
-                <a:ea typeface="+mn-ea"/>
-                <a:cs typeface="+mn-cs"/>
-              </a:rPr>
-              <a:t>This is group work. Your group builds the case for the change your strategy asks of people, in two steps:</a:t>
-            </a:r>
-          </a:p>
-          <a:p>
-            <a:pPr lvl="0"/>
-            <a:endParaRPr lang="en-ZA" sz="1200" b="1" i="0" kern="1200" dirty="0">
-              <a:solidFill>
-                <a:schemeClr val="tx1"/>
-              </a:solidFill>
-              <a:effectLst/>
-              <a:latin typeface="+mn-lt"/>
-              <a:ea typeface="+mn-ea"/>
-              <a:cs typeface="+mn-cs"/>
-            </a:endParaRPr>
-          </a:p>
-          <a:p>
-            <a:endParaRPr lang="en-GB" dirty="0"/>
-          </a:p>
-          <a:p>
-            <a:r>
-              <a:rPr lang="en-GB" b="1" dirty="0"/>
+              <a:rPr lang="en-GB" dirty="0" b="1"/>
               <a:t>1. Brief the step.</a:t>
             </a:r>
           </a:p>
@@ -8700,12 +7876,10 @@
               <a:t>Your group states one Shift, one Stake and one Step for the strategy."</a:t>
             </a:r>
           </a:p>
-          <a:p>
-            <a:endParaRPr lang="en-GB" dirty="0"/>
-          </a:p>
-          <a:p>
-            <a:r>
-              <a:rPr lang="en-GB" b="1" dirty="0"/>
+          <a:p/>
+          <a:p>
+            <a:r>
+              <a:rPr lang="en-GB" dirty="0" b="1"/>
               <a:t>2. Teach each of the three with its guide.</a:t>
             </a:r>
           </a:p>
@@ -8763,9 +7937,7 @@
               <a:t>The group answers: What is changing?</a:t>
             </a:r>
           </a:p>
-          <a:p>
-            <a:endParaRPr lang="en-GB" dirty="0"/>
-          </a:p>
+          <a:p/>
           <a:p>
             <a:r>
               <a:rPr lang="en-GB" dirty="0"/>
@@ -8802,9 +7974,7 @@
               <a:t>The group answers: What will the organisation gain if it changes, and what will it lose if it stays as it is?</a:t>
             </a:r>
           </a:p>
-          <a:p>
-            <a:endParaRPr lang="en-GB" dirty="0"/>
-          </a:p>
+          <a:p/>
           <a:p>
             <a:r>
               <a:rPr lang="en-GB" dirty="0"/>
@@ -8841,15 +8011,24 @@
               <a:t>The group answers: What must be done differently?</a:t>
             </a:r>
           </a:p>
-          <a:p>
-            <a:endParaRPr lang="en-GB" dirty="0"/>
-          </a:p>
-          <a:p>
-            <a:endParaRPr lang="en-GB" dirty="0"/>
-          </a:p>
-          <a:p>
-            <a:r>
-              <a:rPr lang="en-GB" b="1" dirty="0"/>
+          <a:p/>
+          <a:p>
+            <a:r>
+              <a:rPr lang="en-GB" dirty="0" b="1"/>
+              <a:t>3. Bridge to Step 2.</a:t>
+            </a:r>
+          </a:p>
+          <a:p>
+            <a:r>
+              <a:rPr lang="en-GB" dirty="0"/>
+              <a:t>Say: "With the change stated, Step 2 names the leadership behaviours that will hold it in place."</a:t>
+            </a:r>
+          </a:p>
+          <a:p/>
+          <a:p/>
+          <a:p>
+            <a:r>
+              <a:rPr lang="en-GB" dirty="0" b="1"/>
               <a:t>ON THE PORTAL, AFTER THE TEACHING:</a:t>
             </a:r>
           </a:p>
@@ -8875,6 +8054,31 @@
             <a:r>
               <a:rPr lang="en-GB" dirty="0"/>
               <a:t>3. The group agrees its Shift, Stake and Step for the strategy, and each participant writes them in the three boxes.</a:t>
+            </a:r>
+          </a:p>
+          <a:p/>
+          <a:p>
+            <a:r>
+              <a:rPr lang="en-GB" dirty="0" b="1"/>
+              <a:t>LATER, WHEN THE GROUPS DO THE WORK ON THE PORTAL:</a:t>
+            </a:r>
+          </a:p>
+          <a:p>
+            <a:r>
+              <a:rPr lang="en-GB" dirty="0"/>
+              <a:t>The group chooses its scribe for this work. The scribe types what the group agrees, and the entries appear on every member’s page.</a:t>
+            </a:r>
+          </a:p>
+          <a:p>
+            <a:r>
+              <a:rPr lang="en-GB" dirty="0"/>
+              <a:t>Guide each group to test each statement against its guide. A statement that could be said of any organisation has not yet been written for this strategy.</a:t>
+            </a:r>
+          </a:p>
+          <a:p>
+            <a:r>
+              <a:rPr lang="en-GB" dirty="0"/>
+              <a:t>The Shift: the group states what stops, what starts, for whom and from when. The Stake: the group states the gain and what the organisation loses if it stays as it is. The Step: each member states their own part in the first person.</a:t>
             </a:r>
           </a:p>
         </p:txBody>
@@ -9020,356 +8224,360 @@
           <a:lstStyle/>
           <a:p>
             <a:r>
-              <a:rPr lang="en-GB"/>
+              <a:rPr lang="en-GB" dirty="0"/>
               <a:t>SECTION 5 · STEP 2 — ACE-IT (CAPSTONE WORK)</a:t>
             </a:r>
           </a:p>
-          <a:p>
-            <a:endParaRPr lang="en-GB"/>
-          </a:p>
-          <a:p>
-            <a:r>
-              <a:rPr lang="en-GB"/>
+          <a:p/>
+          <a:p>
+            <a:r>
+              <a:rPr lang="en-GB" dirty="0"/>
               <a:t>HOW TO TEACH IT:</a:t>
             </a:r>
           </a:p>
-          <a:p>
-            <a:endParaRPr lang="en-GB"/>
-          </a:p>
-          <a:p>
-            <a:r>
-              <a:rPr lang="en-GB"/>
+          <a:p/>
+          <a:p>
+            <a:r>
+              <a:rPr lang="en-GB" dirty="0"/>
               <a:t>1. Open with the team’s OCEAVL profile.</a:t>
             </a:r>
           </a:p>
           <a:p>
             <a:r>
-              <a:rPr lang="en-GB"/>
+              <a:rPr lang="en-GB" dirty="0"/>
               <a:t>Say: "Your page shows your team’s OCEAVL profile: the team’s level on each dimension, with its risk and its response.</a:t>
             </a:r>
           </a:p>
           <a:p>
             <a:r>
-              <a:rPr lang="en-GB"/>
+              <a:rPr lang="en-GB" dirty="0"/>
               <a:t>It appears once every member of your team has submitted their scores in part 3.1."</a:t>
             </a:r>
           </a:p>
           <a:p>
             <a:r>
-              <a:rPr lang="en-GB"/>
+              <a:rPr lang="en-GB" dirty="0"/>
               <a:t>Where a member has not yet submitted, the profile shows how many have. The group completes 3.1 first.</a:t>
             </a:r>
           </a:p>
-          <a:p>
-            <a:endParaRPr lang="en-GB"/>
-          </a:p>
-          <a:p>
-            <a:r>
-              <a:rPr lang="en-GB"/>
+          <a:p/>
+          <a:p>
+            <a:r>
+              <a:rPr lang="en-GB" dirty="0"/>
               <a:t>Deepen, say: "The same input lands differently depending on the ground it falls on.</a:t>
             </a:r>
           </a:p>
           <a:p>
             <a:r>
-              <a:rPr lang="en-GB"/>
+              <a:rPr lang="en-GB" dirty="0"/>
               <a:t>When a change initiative fails to take, the reflex is to blame the message.</a:t>
             </a:r>
           </a:p>
           <a:p>
             <a:r>
-              <a:rPr lang="en-GB"/>
+              <a:rPr lang="en-GB" dirty="0"/>
               <a:t>First diagnose the conditions stopping good input from rooting."</a:t>
             </a:r>
           </a:p>
           <a:p>
             <a:r>
-              <a:rPr lang="en-GB"/>
+              <a:rPr lang="en-GB" dirty="0"/>
               <a:t>(Insight: Diagnose the soil. Source: Journal, 21 May 2026 — Professional Insights: Culture)</a:t>
             </a:r>
           </a:p>
-          <a:p>
-            <a:endParaRPr lang="en-GB"/>
-          </a:p>
-          <a:p>
-            <a:r>
-              <a:rPr lang="en-GB"/>
+          <a:p/>
+          <a:p>
+            <a:r>
+              <a:rPr lang="en-GB" dirty="0"/>
               <a:t>2. Name the two highest-risk dimensions.</a:t>
             </a:r>
           </a:p>
           <a:p>
             <a:r>
-              <a:rPr lang="en-GB"/>
+              <a:rPr lang="en-GB" dirty="0"/>
               <a:t>Say: "From your team’s profile, your group names the two dimensions on which your executive team carries the highest risk for the strategy, and the response your team adopts for each.</a:t>
             </a:r>
           </a:p>
           <a:p>
             <a:r>
-              <a:rPr lang="en-GB"/>
+              <a:rPr lang="en-GB" dirty="0"/>
               <a:t>The profile gives the risk and the response at your team’s level."</a:t>
             </a:r>
           </a:p>
           <a:p>
             <a:r>
-              <a:rPr lang="en-GB"/>
+              <a:rPr lang="en-GB" dirty="0"/>
               <a:t>Ask: "Which level in your team’s profile carries the highest risk for this change? Which ACE-IT behaviour answers it?"</a:t>
             </a:r>
           </a:p>
-          <a:p>
-            <a:endParaRPr lang="en-GB"/>
-          </a:p>
-          <a:p>
-            <a:r>
-              <a:rPr lang="en-GB"/>
+          <a:p/>
+          <a:p>
+            <a:r>
+              <a:rPr lang="en-GB" dirty="0"/>
               <a:t>3. Teach each of the five behaviours with its guide.</a:t>
             </a:r>
           </a:p>
           <a:p>
             <a:r>
-              <a:rPr lang="en-GB"/>
+              <a:rPr lang="en-GB" dirty="0"/>
               <a:t>The guide beside each box is the lesson of 1.3.4.</a:t>
             </a:r>
           </a:p>
           <a:p>
             <a:r>
-              <a:rPr lang="en-GB"/>
+              <a:rPr lang="en-GB" dirty="0"/>
               <a:t>Accountability</a:t>
             </a:r>
           </a:p>
           <a:p>
             <a:r>
-              <a:rPr lang="en-GB"/>
+              <a:rPr lang="en-GB" dirty="0"/>
               <a:t>Definition: Taking full ownership for results. Acknowledging missteps and driving corrective action.</a:t>
             </a:r>
           </a:p>
           <a:p>
             <a:r>
-              <a:rPr lang="en-GB"/>
+              <a:rPr lang="en-GB" dirty="0"/>
               <a:t>What it does for a new practice: One named person owns the practice and its result.</a:t>
             </a:r>
           </a:p>
           <a:p>
             <a:r>
-              <a:rPr lang="en-GB"/>
+              <a:rPr lang="en-GB" dirty="0"/>
               <a:t>Observable: Commitments tracked • Reviews end with named owners • “We missed it, here’s the fix” language common</a:t>
             </a:r>
           </a:p>
-          <a:p>
-            <a:endParaRPr lang="en-GB"/>
-          </a:p>
-          <a:p>
-            <a:r>
-              <a:rPr lang="en-GB"/>
+          <a:p/>
+          <a:p>
+            <a:r>
+              <a:rPr lang="en-GB" dirty="0"/>
               <a:t>Commitment</a:t>
             </a:r>
           </a:p>
           <a:p>
             <a:r>
-              <a:rPr lang="en-GB"/>
+              <a:rPr lang="en-GB" dirty="0"/>
               <a:t>Definition: Staying anchored to agreed strategic intent even when pressure rises. Following through despite discomfort.</a:t>
             </a:r>
           </a:p>
           <a:p>
             <a:r>
-              <a:rPr lang="en-GB"/>
+              <a:rPr lang="en-GB" dirty="0"/>
               <a:t>What it does for a new practice: The practice is kept when pressure rises and the old way is quicker.</a:t>
             </a:r>
           </a:p>
           <a:p>
             <a:r>
-              <a:rPr lang="en-GB"/>
+              <a:rPr lang="en-GB" dirty="0"/>
               <a:t>Observable: Strategic priorities stay consistent • Leaders decline non-strategic work • Promises kept visibly</a:t>
             </a:r>
           </a:p>
-          <a:p>
-            <a:endParaRPr lang="en-GB"/>
-          </a:p>
-          <a:p>
-            <a:r>
-              <a:rPr lang="en-GB"/>
+          <a:p/>
+          <a:p>
+            <a:r>
+              <a:rPr lang="en-GB" dirty="0"/>
               <a:t>Engagement</a:t>
             </a:r>
           </a:p>
           <a:p>
             <a:r>
-              <a:rPr lang="en-GB"/>
+              <a:rPr lang="en-GB" dirty="0"/>
               <a:t>Definition: Actively involving self and others in sense-making, dialogue, and execution. Listening to understand.</a:t>
             </a:r>
           </a:p>
           <a:p>
             <a:r>
-              <a:rPr lang="en-GB"/>
+              <a:rPr lang="en-GB" dirty="0"/>
               <a:t>What it does for a new practice: People talk about how it is going and improve it together.</a:t>
             </a:r>
           </a:p>
           <a:p>
             <a:r>
-              <a:rPr lang="en-GB"/>
+              <a:rPr lang="en-GB" dirty="0"/>
               <a:t>Observable: Team meetings are two-way • Feedback loops visible • People quote the shared “why”</a:t>
             </a:r>
           </a:p>
-          <a:p>
-            <a:endParaRPr lang="en-GB"/>
-          </a:p>
-          <a:p>
-            <a:r>
-              <a:rPr lang="en-GB"/>
+          <a:p/>
+          <a:p>
+            <a:r>
+              <a:rPr lang="en-GB" dirty="0"/>
               <a:t>Integrity</a:t>
             </a:r>
           </a:p>
           <a:p>
             <a:r>
-              <a:rPr lang="en-GB"/>
+              <a:rPr lang="en-GB" dirty="0"/>
               <a:t>Definition: Acting consistently with values, facts, and truth — even when inconvenient. Declaring conflicts of interest early.</a:t>
             </a:r>
           </a:p>
           <a:p>
             <a:r>
-              <a:rPr lang="en-GB"/>
+              <a:rPr lang="en-GB" dirty="0"/>
               <a:t>What it does for a new practice: Slips are reported as they are, and early.</a:t>
             </a:r>
           </a:p>
           <a:p>
             <a:r>
-              <a:rPr lang="en-GB"/>
+              <a:rPr lang="en-GB" dirty="0"/>
               <a:t>Observable: Evidence cited before decisions • Values referenced in hard choices • Teams trust word matches deed</a:t>
             </a:r>
           </a:p>
-          <a:p>
-            <a:endParaRPr lang="en-GB"/>
-          </a:p>
-          <a:p>
-            <a:r>
-              <a:rPr lang="en-GB"/>
+          <a:p/>
+          <a:p>
+            <a:r>
+              <a:rPr lang="en-GB" dirty="0"/>
               <a:t>Transparency</a:t>
             </a:r>
           </a:p>
           <a:p>
             <a:r>
-              <a:rPr lang="en-GB"/>
+              <a:rPr lang="en-GB" dirty="0"/>
               <a:t>Definition: Making reasoning, progress, and constraints visible to all stakeholders. Sharing challenges openly.</a:t>
             </a:r>
           </a:p>
           <a:p>
             <a:r>
-              <a:rPr lang="en-GB"/>
+              <a:rPr lang="en-GB" dirty="0"/>
               <a:t>What it does for a new practice: Its results are visible to everyone the change affects.</a:t>
             </a:r>
           </a:p>
           <a:p>
             <a:r>
-              <a:rPr lang="en-GB"/>
+              <a:rPr lang="en-GB" dirty="0"/>
               <a:t>Observable: Dashboards updated regularly • Decisions logged and accessible • “No surprises” culture evident</a:t>
             </a:r>
           </a:p>
-          <a:p>
-            <a:endParaRPr lang="en-GB"/>
-          </a:p>
-          <a:p>
-            <a:r>
-              <a:rPr lang="en-GB"/>
+          <a:p/>
+          <a:p>
+            <a:r>
+              <a:rPr lang="en-GB" dirty="0"/>
               <a:t>For each behaviour the group writes: the behaviour we expect from our leadership team.</a:t>
             </a:r>
           </a:p>
-          <a:p>
-            <a:endParaRPr lang="en-GB"/>
-          </a:p>
-          <a:p>
-            <a:r>
-              <a:rPr lang="en-GB"/>
+          <a:p/>
+          <a:p>
+            <a:r>
+              <a:rPr lang="en-GB" dirty="0"/>
               <a:t>4. Give the example.</a:t>
             </a:r>
           </a:p>
-          <a:p>
-            <a:endParaRPr lang="en-GB"/>
-          </a:p>
-          <a:p>
-            <a:r>
-              <a:rPr lang="en-GB"/>
+          <a:p/>
+          <a:p>
+            <a:r>
+              <a:rPr lang="en-GB" dirty="0"/>
               <a:t>EXAMPLE</a:t>
             </a:r>
           </a:p>
           <a:p>
             <a:r>
-              <a:rPr lang="en-GB"/>
+              <a:rPr lang="en-GB" dirty="0"/>
               <a:t>The team’s level on Agreeableness is High.</a:t>
             </a:r>
           </a:p>
           <a:p>
             <a:r>
-              <a:rPr lang="en-GB"/>
+              <a:rPr lang="en-GB" dirty="0"/>
               <a:t>Risk: Agreement given without genuine commitment; team over-commits; resentment builds beneath surface harmony.</a:t>
             </a:r>
           </a:p>
           <a:p>
             <a:r>
-              <a:rPr lang="en-GB"/>
+              <a:rPr lang="en-GB" dirty="0"/>
               <a:t>Expected behaviour under Commitment: “Each of us states our capacity before we accept new work for this change.”</a:t>
             </a:r>
           </a:p>
-          <a:p>
-            <a:endParaRPr lang="en-GB"/>
-          </a:p>
-          <a:p>
-            <a:r>
-              <a:rPr lang="en-GB"/>
+          <a:p/>
+          <a:p>
+            <a:r>
+              <a:rPr lang="en-GB" dirty="0" b="1"/>
+              <a:t>5. Bridge to the Unit Summary.</a:t>
+            </a:r>
+          </a:p>
+          <a:p>
+            <a:r>
+              <a:rPr lang="en-GB" dirty="0"/>
+              <a:t>Say: "With the change and the behaviours stated, we close the unit."</a:t>
+            </a:r>
+          </a:p>
+          <a:p/>
+          <a:p>
+            <a:r>
+              <a:rPr lang="en-GB" dirty="0" b="1"/>
+              <a:t>LATER, WHEN THE GROUPS DO THE WORK ON THE PORTAL:</a:t>
+            </a:r>
+          </a:p>
+          <a:p>
+            <a:r>
+              <a:rPr lang="en-GB" dirty="0"/>
+              <a:t>The group opens with its team OCEAVL profile. Where a member has not yet submitted, the profile shows how many have; that member completes 3.1 first.</a:t>
+            </a:r>
+          </a:p>
+          <a:p>
+            <a:r>
+              <a:rPr lang="en-GB" dirty="0"/>
+              <a:t>Each behaviour: the group writes what a colleague would see the leadership team do. A value such as “we will be accountable” becomes a behaviour once it is stated that way.</a:t>
+            </a:r>
+          </a:p>
+          <a:p>
+            <a:r>
+              <a:rPr lang="en-GB" dirty="0"/>
+              <a:t>Whose behaviour: the five boxes hold the leadership team’s own behaviour.</a:t>
+            </a:r>
+          </a:p>
+          <a:p/>
+          <a:p>
+            <a:r>
+              <a:rPr lang="en-GB" dirty="0"/>
               <a:t>ON THE PORTAL, AFTER THE TEACHING:</a:t>
             </a:r>
           </a:p>
           <a:p>
             <a:r>
-              <a:rPr lang="en-GB"/>
+              <a:rPr lang="en-GB" dirty="0"/>
               <a:t>Participants work as a group in Step 2 of Section 5 of the participant file. This is Capstone work.</a:t>
             </a:r>
           </a:p>
           <a:p>
             <a:r>
-              <a:rPr lang="en-GB"/>
+              <a:rPr lang="en-GB" dirty="0"/>
               <a:t>1. The group reads its team OCEAVL profile, shown on each page once every member of the team has submitted their scores in part 3.1.</a:t>
             </a:r>
           </a:p>
           <a:p>
             <a:r>
-              <a:rPr lang="en-GB"/>
+              <a:rPr lang="en-GB" dirty="0"/>
               <a:t>2. The group names the two dimensions on which its executive team carries the highest risk for the strategy, and the response it adopts for each.</a:t>
             </a:r>
           </a:p>
           <a:p>
             <a:r>
-              <a:rPr lang="en-GB"/>
+              <a:rPr lang="en-GB" dirty="0"/>
               <a:t>3. The group reads the guide in each card. It is the lesson from part 1.3.4.</a:t>
             </a:r>
           </a:p>
           <a:p>
             <a:r>
-              <a:rPr lang="en-GB"/>
+              <a:rPr lang="en-GB" dirty="0"/>
               <a:t>4. For each behaviour, the group agrees what it expects to see the leadership team do so that the change in Step 1 holds. Where the team’s level carries a risk for this change, the group states the behaviour that answers it.</a:t>
             </a:r>
           </a:p>
           <a:p>
             <a:r>
-              <a:rPr lang="en-GB"/>
+              <a:rPr lang="en-GB" dirty="0"/>
               <a:t>5. Each participant reads the record and selects Agree. Print gives a copy of the record.</a:t>
             </a:r>
           </a:p>
-          <a:p>
-            <a:endParaRPr lang="en-GB"/>
-          </a:p>
-          <a:p>
-            <a:r>
-              <a:rPr lang="en-GB"/>
-              <a:t>AFTER THE SESSION:</a:t>
-            </a:r>
-          </a:p>
-          <a:p>
-            <a:r>
-              <a:rPr lang="en-GB"/>
-              <a:t>The record reaches you with each participant’s submission, under the heading Leading with Clarity.</a:t>
-            </a:r>
-          </a:p>
-          <a:p>
-            <a:r>
-              <a:rPr lang="en-GB"/>
-              <a:t>The agreed record feeds boxes 5A to 5C of the team’s Capstone Blueprint: the two highest-risk dimensions in 5A, the Shift, Stake and Step in 5B, the expected leadership behaviours in 5C.</a:t>
+          <a:p/>
+          <a:p>
+            <a:r>
+              <a:rPr lang="en-GB" dirty="0" b="1"/>
+              <a:t>WHERE THE RECORD GOES:</a:t>
+            </a:r>
+          </a:p>
+          <a:p>
+            <a:r>
+              <a:rPr lang="en-GB" dirty="0"/>
+              <a:t>The agreed record feeds boxes 5A to 5C of the team’s Capstone S2R® Blueprint: the two highest-risk dimensions in 5A, the Shift, Stake and Step in 5B, the expected leadership behaviours in 5C.</a:t>
             </a:r>
           </a:p>
         </p:txBody>
@@ -9515,173 +8723,154 @@
           <a:lstStyle/>
           <a:p>
             <a:r>
-              <a:rPr lang="en-GB"/>
+              <a:rPr lang="en-GB" dirty="0"/>
               <a:t>UNIT SUMMARY (UNIT 5 SYNTHESIS)</a:t>
             </a:r>
           </a:p>
-          <a:p>
-            <a:endParaRPr lang="en-GB"/>
-          </a:p>
-          <a:p>
-            <a:r>
-              <a:rPr lang="en-GB"/>
+          <a:p/>
+          <a:p>
+            <a:r>
+              <a:rPr lang="en-GB" dirty="0"/>
               <a:t>HOW TO TEACH IT:</a:t>
             </a:r>
           </a:p>
-          <a:p>
-            <a:endParaRPr lang="en-GB"/>
-          </a:p>
-          <a:p>
-            <a:r>
-              <a:rPr lang="en-GB"/>
+          <a:p/>
+          <a:p>
+            <a:r>
+              <a:rPr lang="en-GB" dirty="0"/>
               <a:t>1. Recap the unit, section by section.</a:t>
             </a:r>
           </a:p>
           <a:p>
             <a:r>
-              <a:rPr lang="en-GB"/>
+              <a:rPr lang="en-GB" dirty="0"/>
               <a:t>Say: "This session was about the human conditions that decide whether a strategy ever moves.</a:t>
             </a:r>
           </a:p>
           <a:p>
             <a:r>
-              <a:rPr lang="en-GB"/>
+              <a:rPr lang="en-GB" dirty="0"/>
               <a:t>Aligning Heart &amp; Mind treated execution as first a human problem: strategy moves through people before it moves through systems."</a:t>
             </a:r>
           </a:p>
           <a:p>
             <a:r>
-              <a:rPr lang="en-GB"/>
+              <a:rPr lang="en-GB" dirty="0"/>
               <a:t>- 1 · Awareness: strategy enters through Cognition (Mind) and Emotion (Heart). Five principles describe how alignment is created and sustained.</a:t>
             </a:r>
           </a:p>
           <a:p>
             <a:r>
-              <a:rPr lang="en-GB"/>
+              <a:rPr lang="en-GB" dirty="0"/>
               <a:t>- 2 · Intelligence: Heart &amp; Mind alignment is the ignition point that converts strategic potential energy into kinetic energy. Compliance yields short-term output. Commitment sustains execution when leaders are not present.</a:t>
             </a:r>
           </a:p>
           <a:p>
             <a:r>
-              <a:rPr lang="en-GB"/>
+              <a:rPr lang="en-GB" dirty="0"/>
               <a:t>- 3 · Extrapolating: each participant completes the OCEAVL Assessment across seven dimensions. The level held by most members is the team’s level, and every level carries a risk, a response and three routines.</a:t>
             </a:r>
           </a:p>
           <a:p>
             <a:r>
-              <a:rPr lang="en-GB"/>
+              <a:rPr lang="en-GB" dirty="0"/>
               <a:t>- 4 · Integration: the leadership team leads change with one voice through four commitments. Each CXO role brings a Converging Zone Contribution and carries an Alignment Hot Zone.</a:t>
             </a:r>
           </a:p>
           <a:p>
             <a:r>
-              <a:rPr lang="en-GB"/>
+              <a:rPr lang="en-GB" dirty="0"/>
               <a:t>- 5 · Application: each group states its Shift, Stake and Step for the strategy, reads its team OCEAVL profile, names its two highest-risk dimensions with the response to each, and states the ACE-IT behaviours it expects from the leadership team.</a:t>
             </a:r>
           </a:p>
           <a:p>
             <a:r>
-              <a:rPr lang="en-GB"/>
+              <a:rPr lang="en-GB" dirty="0"/>
               <a:t>- Across the unit: a change is adopted when it passes the 4 Checks of Mind, Heart, Hands and Habit. The leader’s job is to explain, involve, equip and reinforce until it passes all four.</a:t>
             </a:r>
           </a:p>
-          <a:p>
-            <a:endParaRPr lang="en-GB"/>
-          </a:p>
-          <a:p>
-            <a:r>
-              <a:rPr lang="en-GB"/>
+          <a:p/>
+          <a:p>
+            <a:r>
+              <a:rPr lang="en-GB" dirty="0"/>
               <a:t>2. Ask the closing question on the slide.</a:t>
             </a:r>
           </a:p>
           <a:p>
             <a:r>
-              <a:rPr lang="en-GB"/>
+              <a:rPr lang="en-GB" dirty="0"/>
               <a:t>Ask: "Which ACE-IT behaviour in your record will be hardest for this leadership team to show, and what in the team’s OCEAVL profile makes it so?"</a:t>
             </a:r>
           </a:p>
           <a:p>
             <a:r>
-              <a:rPr lang="en-GB"/>
+              <a:rPr lang="en-GB" dirty="0"/>
               <a:t>Take an answer from each group.</a:t>
             </a:r>
           </a:p>
-          <a:p>
-            <a:endParaRPr lang="en-GB"/>
-          </a:p>
-          <a:p>
-            <a:r>
-              <a:rPr lang="en-GB"/>
+          <a:p/>
+          <a:p>
+            <a:r>
+              <a:rPr lang="en-GB" dirty="0"/>
               <a:t>3. Close the unit.</a:t>
             </a:r>
           </a:p>
           <a:p>
             <a:r>
-              <a:rPr lang="en-GB"/>
+              <a:rPr lang="en-GB" dirty="0"/>
               <a:t>Say: "Aligned hearts and minds turn a strategy from a document the organisation has read into a direction the organisation is willing to move on."</a:t>
             </a:r>
           </a:p>
           <a:p>
             <a:r>
-              <a:rPr lang="en-GB"/>
-              <a:t>Connect the unit to what follows: Performance Management Setup and the translation of strategy into individual accountability across the enterprise.</a:t>
-            </a:r>
-          </a:p>
-          <a:p>
-            <a:endParaRPr lang="en-GB"/>
-          </a:p>
-          <a:p>
-            <a:r>
-              <a:rPr lang="en-GB"/>
-              <a:t>4. Say what happens on the portal.</a:t>
-            </a:r>
-          </a:p>
-          <a:p>
-            <a:r>
-              <a:rPr lang="en-GB"/>
-              <a:t>Say: "You now complete the unit on the portal: your reflections, your OCEAVL Assessment and your group’s record in Section 5.</a:t>
-            </a:r>
-          </a:p>
-          <a:p>
-            <a:r>
-              <a:rPr lang="en-GB"/>
-              <a:t>When your page is complete, you submit the unit."</a:t>
-            </a:r>
-          </a:p>
-          <a:p>
-            <a:endParaRPr lang="en-GB"/>
-          </a:p>
-          <a:p>
-            <a:r>
-              <a:rPr lang="en-GB"/>
+              <a:rPr lang="en-GB" dirty="0"/>
+              <a:t>Say: "Each group has stated the change and the leadership behaviours that will hold it in place."</a:t>
+            </a:r>
+          </a:p>
+          <a:p/>
+          <a:p>
+            <a:r>
+              <a:rPr lang="en-GB" dirty="0" b="1"/>
+              <a:t>4. Bridge to Unit 6.</a:t>
+            </a:r>
+          </a:p>
+          <a:p>
+            <a:r>
+              <a:rPr lang="en-GB" dirty="0"/>
+              <a:t>Say: "Unit 6 builds the system that connects enterprise results to the contributions of people and the conditions the organisation provides."</a:t>
+            </a:r>
+          </a:p>
+          <a:p/>
+          <a:p/>
+          <a:p>
+            <a:r>
+              <a:rPr lang="en-GB" dirty="0"/>
               <a:t>ON THE PORTAL, AFTER THE TEACHING:</a:t>
             </a:r>
           </a:p>
           <a:p>
             <a:r>
-              <a:rPr lang="en-GB"/>
-              <a:t>Participants complete every part of the participant file and submit the unit to the facilitator from the end of Section 5.</a:t>
-            </a:r>
-          </a:p>
-          <a:p>
-            <a:endParaRPr lang="en-GB"/>
-          </a:p>
-          <a:p>
-            <a:r>
-              <a:rPr lang="en-GB"/>
+              <a:rPr lang="en-GB" dirty="0"/>
+              <a:t>Participants complete every part of the participant file: the thirteen reflections, the OCEAVL Assessment and the group’s record in Section 5. When the page is complete, each participant submits the unit to the facilitator from the end of Section 5.</a:t>
+            </a:r>
+          </a:p>
+          <a:p/>
+          <a:p>
+            <a:r>
+              <a:rPr lang="en-GB" dirty="0"/>
               <a:t>AFTER THE SESSION:</a:t>
             </a:r>
           </a:p>
           <a:p>
             <a:r>
-              <a:rPr lang="en-GB"/>
+              <a:rPr lang="en-GB" dirty="0"/>
               <a:t>Each submission reaches you in the facilitator dashboard.</a:t>
             </a:r>
           </a:p>
           <a:p>
             <a:r>
-              <a:rPr lang="en-GB"/>
-              <a:t>Each member’s OCEAVL scores feed the team’s profile in the Capstone Blueprint. The group’s confirmed record feeds boxes 5B and 5C.</a:t>
+              <a:rPr lang="en-GB" dirty="0"/>
+              <a:t>Each member’s OCEAVL scores feed the team’s profile in the Capstone S2R® Blueprint. The group’s agreed record feeds boxes 5A to 5C.</a:t>
             </a:r>
           </a:p>
         </p:txBody>
@@ -13143,8 +12332,8 @@
         </p:nvSpPr>
         <p:spPr>
           <a:xfrm>
-            <a:off x="548640" y="5623560"/>
-            <a:ext cx="11091672" cy="777240"/>
+            <a:off x="548640" y="5486400"/>
+            <a:ext cx="11091672" cy="960120"/>
           </a:xfrm>
           <a:prstGeom prst="roundRect">
             <a:avLst>
@@ -13177,8 +12366,8 @@
         </p:nvSpPr>
         <p:spPr>
           <a:xfrm>
-            <a:off x="822960" y="5623560"/>
-            <a:ext cx="10607040" cy="777240"/>
+            <a:off x="822960" y="5486400"/>
+            <a:ext cx="10607040" cy="960120"/>
           </a:xfrm>
           <a:prstGeom prst="rect">
             <a:avLst/>
@@ -14361,8 +13550,8 @@
         </p:nvSpPr>
         <p:spPr>
           <a:xfrm>
-            <a:off x="548640" y="5623560"/>
-            <a:ext cx="11091672" cy="777240"/>
+            <a:off x="548640" y="5486400"/>
+            <a:ext cx="11091672" cy="960120"/>
           </a:xfrm>
           <a:prstGeom prst="roundRect">
             <a:avLst>
@@ -14395,8 +13584,8 @@
         </p:nvSpPr>
         <p:spPr>
           <a:xfrm>
-            <a:off x="822960" y="5623560"/>
-            <a:ext cx="10607040" cy="777240"/>
+            <a:off x="822960" y="5486400"/>
+            <a:ext cx="10607040" cy="960120"/>
           </a:xfrm>
           <a:prstGeom prst="rect">
             <a:avLst/>
@@ -15238,7 +14427,7 @@
         <p:spPr>
           <a:xfrm>
             <a:off x="777240" y="2560320"/>
-            <a:ext cx="4951476" cy="640080"/>
+            <a:ext cx="4951476" cy="749808"/>
           </a:xfrm>
           <a:prstGeom prst="rect">
             <a:avLst/>
@@ -15406,7 +14595,7 @@
         <p:spPr>
           <a:xfrm>
             <a:off x="6460236" y="2560320"/>
-            <a:ext cx="4951476" cy="640080"/>
+            <a:ext cx="4951476" cy="749808"/>
           </a:xfrm>
           <a:prstGeom prst="rect">
             <a:avLst/>
@@ -15574,7 +14763,7 @@
         <p:spPr>
           <a:xfrm>
             <a:off x="777240" y="4663440"/>
-            <a:ext cx="4951476" cy="640080"/>
+            <a:ext cx="4951476" cy="749808"/>
           </a:xfrm>
           <a:prstGeom prst="rect">
             <a:avLst/>
@@ -15742,7 +14931,7 @@
         <p:spPr>
           <a:xfrm>
             <a:off x="6460236" y="4663440"/>
-            <a:ext cx="4951476" cy="640080"/>
+            <a:ext cx="4951476" cy="749808"/>
           </a:xfrm>
           <a:prstGeom prst="rect">
             <a:avLst/>
@@ -16917,7 +16106,7 @@
         </p:blipFill>
         <p:spPr>
           <a:xfrm>
-            <a:off x="1691640" y="1572768"/>
+            <a:off x="1691640" y="1371600"/>
             <a:ext cx="9921240" cy="1059836"/>
           </a:xfrm>
           <a:prstGeom prst="rect">
@@ -16933,7 +16122,7 @@
         </p:nvSpPr>
         <p:spPr>
           <a:xfrm>
-            <a:off x="548640" y="1668345"/>
+            <a:off x="548640" y="1467178"/>
             <a:ext cx="868680" cy="868680"/>
           </a:xfrm>
           <a:prstGeom prst="ellipse">
@@ -16996,7 +16185,7 @@
         </p:blipFill>
         <p:spPr>
           <a:xfrm>
-            <a:off x="1691640" y="2925211"/>
+            <a:off x="1691640" y="2670048"/>
             <a:ext cx="9921240" cy="1059836"/>
           </a:xfrm>
           <a:prstGeom prst="rect">
@@ -17012,7 +16201,7 @@
         </p:nvSpPr>
         <p:spPr>
           <a:xfrm>
-            <a:off x="548640" y="3020788"/>
+            <a:off x="548640" y="2765626"/>
             <a:ext cx="868680" cy="868680"/>
           </a:xfrm>
           <a:prstGeom prst="ellipse">
@@ -17075,7 +16264,7 @@
         </p:blipFill>
         <p:spPr>
           <a:xfrm>
-            <a:off x="1691640" y="4277654"/>
+            <a:off x="1691640" y="3968496"/>
             <a:ext cx="9921240" cy="1059836"/>
           </a:xfrm>
           <a:prstGeom prst="rect">
@@ -17091,7 +16280,7 @@
         </p:nvSpPr>
         <p:spPr>
           <a:xfrm>
-            <a:off x="548640" y="4373231"/>
+            <a:off x="548640" y="4064074"/>
             <a:ext cx="868680" cy="868680"/>
           </a:xfrm>
           <a:prstGeom prst="ellipse">
@@ -17154,7 +16343,7 @@
         </p:blipFill>
         <p:spPr>
           <a:xfrm>
-            <a:off x="1691640" y="5630097"/>
+            <a:off x="1691640" y="5266944"/>
             <a:ext cx="9921240" cy="1251195"/>
           </a:xfrm>
           <a:prstGeom prst="rect">
@@ -17170,7 +16359,7 @@
         </p:nvSpPr>
         <p:spPr>
           <a:xfrm>
-            <a:off x="548640" y="5821354"/>
+            <a:off x="548640" y="5458201"/>
             <a:ext cx="868680" cy="868680"/>
           </a:xfrm>
           <a:prstGeom prst="ellipse">
@@ -18877,8 +18066,8 @@
         </p:nvSpPr>
         <p:spPr>
           <a:xfrm>
-            <a:off x="548640" y="5623560"/>
-            <a:ext cx="11091672" cy="777240"/>
+            <a:off x="548640" y="5486400"/>
+            <a:ext cx="11091672" cy="960120"/>
           </a:xfrm>
           <a:prstGeom prst="roundRect">
             <a:avLst>
@@ -18911,8 +18100,8 @@
         </p:nvSpPr>
         <p:spPr>
           <a:xfrm>
-            <a:off x="822960" y="5623560"/>
-            <a:ext cx="10607040" cy="777240"/>
+            <a:off x="822960" y="5486400"/>
+            <a:ext cx="10607040" cy="960120"/>
           </a:xfrm>
           <a:prstGeom prst="rect">
             <a:avLst/>
@@ -21807,7 +20996,7 @@
         <p:spPr>
           <a:xfrm>
             <a:off x="1508760" y="1691640"/>
-            <a:ext cx="4219956" cy="594360"/>
+            <a:ext cx="4219956" cy="713232"/>
           </a:xfrm>
           <a:prstGeom prst="rect">
             <a:avLst/>
@@ -21997,7 +21186,7 @@
         <p:spPr>
           <a:xfrm>
             <a:off x="7191756" y="1691640"/>
-            <a:ext cx="4219956" cy="594360"/>
+            <a:ext cx="4219956" cy="713232"/>
           </a:xfrm>
           <a:prstGeom prst="rect">
             <a:avLst/>
@@ -22187,7 +21376,7 @@
         <p:spPr>
           <a:xfrm>
             <a:off x="1508760" y="4251960"/>
-            <a:ext cx="4219956" cy="594360"/>
+            <a:ext cx="4219956" cy="713232"/>
           </a:xfrm>
           <a:prstGeom prst="rect">
             <a:avLst/>
@@ -22377,7 +21566,7 @@
         <p:spPr>
           <a:xfrm>
             <a:off x="7191756" y="4251960"/>
-            <a:ext cx="4219956" cy="594360"/>
+            <a:ext cx="4219956" cy="713232"/>
           </a:xfrm>
           <a:prstGeom prst="rect">
             <a:avLst/>
@@ -23165,8 +22354,8 @@
         </p:blipFill>
         <p:spPr>
           <a:xfrm>
-            <a:off x="548640" y="1009934"/>
-            <a:ext cx="5227093" cy="5920398"/>
+            <a:off x="548640" y="1417320"/>
+            <a:ext cx="4688737" cy="5303520"/>
           </a:xfrm>
           <a:prstGeom prst="rect">
             <a:avLst/>
@@ -23196,8 +22385,8 @@
         </p:blipFill>
         <p:spPr>
           <a:xfrm>
-            <a:off x="6856635" y="1120289"/>
-            <a:ext cx="4708478" cy="5737711"/>
+            <a:off x="7284151" y="1417320"/>
+            <a:ext cx="4356160" cy="5303520"/>
           </a:xfrm>
           <a:prstGeom prst="rect">
             <a:avLst/>
@@ -25247,7 +24436,7 @@
                 <a:ea typeface="Calibri" pitchFamily="34" charset="-122"/>
                 <a:cs typeface="Calibri" pitchFamily="34" charset="-120"/>
               </a:rPr>
-              <a:t>Your group states three things for the strategy in your Capstone Blueprint.</a:t>
+              <a:t>Your group states three things for the strategy in your Capstone S2R Blueprint.</a:t>
             </a:r>
             <a:endParaRPr kumimoji="0" lang="en-US" sz="2400" b="0" i="0" u="none" strike="noStrike" kern="1200" cap="none" spc="0" normalizeH="0" baseline="0" noProof="0" dirty="0">
               <a:ln>
@@ -29469,8 +28658,8 @@
         </p:nvSpPr>
         <p:spPr>
           <a:xfrm>
-            <a:off x="548640" y="5623560"/>
-            <a:ext cx="11091672" cy="777240"/>
+            <a:off x="548640" y="5486400"/>
+            <a:ext cx="11091672" cy="960120"/>
           </a:xfrm>
           <a:prstGeom prst="roundRect">
             <a:avLst>
@@ -29503,8 +28692,8 @@
         </p:nvSpPr>
         <p:spPr>
           <a:xfrm>
-            <a:off x="822960" y="5623560"/>
-            <a:ext cx="10607040" cy="777240"/>
+            <a:off x="822960" y="5486400"/>
+            <a:ext cx="10607040" cy="960120"/>
           </a:xfrm>
           <a:prstGeom prst="rect">
             <a:avLst/>

</xml_diff>